<commit_message>
Scope to 50Salads only; two-track plan (HAL now, InternVideo2 when video)
Decision: focus on 50Salads only for now -> all work goes through the WLTA
code (runs 50S natively as -d FS -c 19, modes --model_type atba / wclot).
No Breakfast, no standalone HAL.

- docs/baselines-hal-cva.md: HAL plan H1-H7 rewritten as 50Salads-only-via-WLTA
  (run DELTA/WLTA atba+wclot -> dump tas_pseudolabels -> score Y* -> port HAL's
  VAE tap + recon/kl/diff into atba_loss.py -> compare Y* + Obs%/Pred% MoC ->
  ablate). Added VLM track V1-V6 with InternVideo2 (OpenGVLab/InternVideo2,
  video-native, > CVA's SlowFast+CLIP). HAL track needs NO raw video; only the
  VLM track is blocked on it.
- plan file: sequencing table -> two tracks, 50Salads only.
- slides: new "Scope - 50Salads only" slide; HAL slide -> H1-H7 via WLTA;
  VLM slide -> InternVideo2 V1-V6; two-track sequencing. 21 slides.
</commit_message>
<xml_diff>
--- a/slides/DELTA_progress_Mariella.pptx
+++ b/slides/DELTA_progress_Mariella.pptx
@@ -3751,6 +3751,22 @@
               <a:t>▸ Not a drop-in baseline (wrong task/supervision) — the methodological reference. CBD and CTE are directly transferable to our aligned pseudo-boundaries.</a:t>
             </a:r>
           </a:p>
+          <a:p>
+            <a:pPr>
+              <a:spcAft>
+                <a:spcPts val="600"/>
+              </a:spcAft>
+            </a:pPr>
+            <a:r>
+              <a:rPr sz="1700" b="0">
+                <a:solidFill>
+                  <a:srgbClr val="22262B"/>
+                </a:solidFill>
+                <a:latin typeface="Calibri"/>
+              </a:rPr>
+              <a:t>▸ We'd use InternVideo2 (video-native) as the VLM, not CVA's SlowFast + frame-CLIP.</a:t>
+            </a:r>
+          </a:p>
         </p:txBody>
       </p:sp>
     </p:spTree>
@@ -4904,7 +4920,7 @@
                 </a:solidFill>
                 <a:latin typeface="Calibri"/>
               </a:rPr>
-              <a:t>The TA plan — phases (shared)</a:t>
+              <a:t>Scope — 50Salads only, for now</a:t>
             </a:r>
           </a:p>
           <a:p>
@@ -4915,7 +4931,7 @@
                 </a:solidFill>
                 <a:latin typeface="Calibri"/>
               </a:rPr>
-              <a:t>phase 0 runs now on I3D; phases 1–4 need raw 50Salads video</a:t>
+              <a:t>one dataset · one codebase · two tracks</a:t>
             </a:r>
           </a:p>
         </p:txBody>
@@ -4963,574 +4979,157 @@
           </a:p>
         </p:txBody>
       </p:sp>
-      <p:graphicFrame>
-        <p:nvGraphicFramePr>
-          <p:cNvPr id="4" name="Table 3"/>
-          <p:cNvGraphicFramePr>
-            <a:graphicFrameLocks noGrp="1"/>
-          </p:cNvGraphicFramePr>
+      <p:sp>
+        <p:nvSpPr>
+          <p:cNvPr id="4" name="TextBox 3"/>
+          <p:cNvSpPr txBox="1"/>
           <p:nvPr/>
-        </p:nvGraphicFramePr>
-        <p:xfrm>
-          <a:off x="548640" y="1645920"/>
-          <a:ext cx="11430000" cy="2194560"/>
-        </p:xfrm>
-        <a:graphic>
-          <a:graphicData uri="http://schemas.openxmlformats.org/drawingml/2006/table">
-            <a:tbl>
-              <a:tblPr firstRow="1" bandRow="1">
-                <a:tableStyleId>{5C22544A-7EE6-4342-B048-85BDC9FD1C3A}</a:tableStyleId>
-              </a:tblPr>
-              <a:tblGrid>
-                <a:gridCol w="640080"/>
-                <a:gridCol w="6035040"/>
-                <a:gridCol w="1737360"/>
-                <a:gridCol w="3017520"/>
-              </a:tblGrid>
-              <a:tr h="365760">
-                <a:tc>
-                  <a:txBody>
-                    <a:bodyPr/>
-                    <a:lstStyle/>
-                    <a:p>
-                      <a:r>
-                        <a:rPr sz="1150" b="1">
-                          <a:solidFill>
-                            <a:srgbClr val="FFFFFF"/>
-                          </a:solidFill>
-                          <a:latin typeface="Calibri"/>
-                        </a:rPr>
-                        <a:t>Phase</a:t>
-                      </a:r>
-                    </a:p>
-                  </a:txBody>
-                  <a:tcPr>
-                    <a:solidFill>
-                      <a:srgbClr val="1F3A5F"/>
-                    </a:solidFill>
-                  </a:tcPr>
-                </a:tc>
-                <a:tc>
-                  <a:txBody>
-                    <a:bodyPr/>
-                    <a:lstStyle/>
-                    <a:p>
-                      <a:r>
-                        <a:rPr sz="1150" b="1">
-                          <a:solidFill>
-                            <a:srgbClr val="FFFFFF"/>
-                          </a:solidFill>
-                          <a:latin typeface="Calibri"/>
-                        </a:rPr>
-                        <a:t>Work</a:t>
-                      </a:r>
-                    </a:p>
-                  </a:txBody>
-                  <a:tcPr>
-                    <a:solidFill>
-                      <a:srgbClr val="1F3A5F"/>
-                    </a:solidFill>
-                  </a:tcPr>
-                </a:tc>
-                <a:tc>
-                  <a:txBody>
-                    <a:bodyPr/>
-                    <a:lstStyle/>
-                    <a:p>
-                      <a:r>
-                        <a:rPr sz="1150" b="1">
-                          <a:solidFill>
-                            <a:srgbClr val="FFFFFF"/>
-                          </a:solidFill>
-                          <a:latin typeface="Calibri"/>
-                        </a:rPr>
-                        <a:t>Needs</a:t>
-                      </a:r>
-                    </a:p>
-                  </a:txBody>
-                  <a:tcPr>
-                    <a:solidFill>
-                      <a:srgbClr val="1F3A5F"/>
-                    </a:solidFill>
-                  </a:tcPr>
-                </a:tc>
-                <a:tc>
-                  <a:txBody>
-                    <a:bodyPr/>
-                    <a:lstStyle/>
-                    <a:p>
-                      <a:r>
-                        <a:rPr sz="1150" b="1">
-                          <a:solidFill>
-                            <a:srgbClr val="FFFFFF"/>
-                          </a:solidFill>
-                          <a:latin typeface="Calibri"/>
-                        </a:rPr>
-                        <a:t>Output</a:t>
-                      </a:r>
-                    </a:p>
-                  </a:txBody>
-                  <a:tcPr>
-                    <a:solidFill>
-                      <a:srgbClr val="1F3A5F"/>
-                    </a:solidFill>
-                  </a:tcPr>
-                </a:tc>
-              </a:tr>
-              <a:tr h="365760">
-                <a:tc>
-                  <a:txBody>
-                    <a:bodyPr/>
-                    <a:lstStyle/>
-                    <a:p>
-                      <a:r>
-                        <a:rPr sz="1050">
-                          <a:solidFill>
-                            <a:srgbClr val="22262B"/>
-                          </a:solidFill>
-                          <a:latin typeface="Calibri"/>
-                        </a:rPr>
-                        <a:t>0</a:t>
-                      </a:r>
-                    </a:p>
-                  </a:txBody>
-                  <a:tcPr>
-                    <a:solidFill>
-                      <a:srgbClr val="FFFFFF"/>
-                    </a:solidFill>
-                  </a:tcPr>
-                </a:tc>
-                <a:tc>
-                  <a:txBody>
-                    <a:bodyPr/>
-                    <a:lstStyle/>
-                    <a:p>
-                      <a:r>
-                        <a:rPr sz="1050">
-                          <a:solidFill>
-                            <a:srgbClr val="22262B"/>
-                          </a:solidFill>
-                          <a:latin typeface="Calibri"/>
-                        </a:rPr>
-                        <a:t>Baselines: DELTA/WLTA --model_type atba + wclot on Breakfast &amp; 50S; extract pseudo-labels; measure boundary quality</a:t>
-                      </a:r>
-                    </a:p>
-                  </a:txBody>
-                  <a:tcPr>
-                    <a:solidFill>
-                      <a:srgbClr val="FFFFFF"/>
-                    </a:solidFill>
-                  </a:tcPr>
-                </a:tc>
-                <a:tc>
-                  <a:txBody>
-                    <a:bodyPr/>
-                    <a:lstStyle/>
-                    <a:p>
-                      <a:r>
-                        <a:rPr sz="1050">
-                          <a:solidFill>
-                            <a:srgbClr val="22262B"/>
-                          </a:solidFill>
-                          <a:latin typeface="Calibri"/>
-                        </a:rPr>
-                        <a:t>cluster, I3D</a:t>
-                      </a:r>
-                    </a:p>
-                  </a:txBody>
-                  <a:tcPr>
-                    <a:solidFill>
-                      <a:srgbClr val="FFFFFF"/>
-                    </a:solidFill>
-                  </a:tcPr>
-                </a:tc>
-                <a:tc>
-                  <a:txBody>
-                    <a:bodyPr/>
-                    <a:lstStyle/>
-                    <a:p>
-                      <a:r>
-                        <a:rPr sz="1050">
-                          <a:solidFill>
-                            <a:srgbClr val="22262B"/>
-                          </a:solidFill>
-                          <a:latin typeface="Calibri"/>
-                        </a:rPr>
-                        <a:t>real MoC; the reference table</a:t>
-                      </a:r>
-                    </a:p>
-                  </a:txBody>
-                  <a:tcPr>
-                    <a:solidFill>
-                      <a:srgbClr val="FFFFFF"/>
-                    </a:solidFill>
-                  </a:tcPr>
-                </a:tc>
-              </a:tr>
-              <a:tr h="365760">
-                <a:tc>
-                  <a:txBody>
-                    <a:bodyPr/>
-                    <a:lstStyle/>
-                    <a:p>
-                      <a:r>
-                        <a:rPr sz="1050">
-                          <a:solidFill>
-                            <a:srgbClr val="22262B"/>
-                          </a:solidFill>
-                          <a:latin typeface="Calibri"/>
-                        </a:rPr>
-                        <a:t>1</a:t>
-                      </a:r>
-                    </a:p>
-                  </a:txBody>
-                  <a:tcPr>
-                    <a:solidFill>
-                      <a:srgbClr val="ECEEF1"/>
-                    </a:solidFill>
-                  </a:tcPr>
-                </a:tc>
-                <a:tc>
-                  <a:txBody>
-                    <a:bodyPr/>
-                    <a:lstStyle/>
-                    <a:p>
-                      <a:r>
-                        <a:rPr sz="1050">
-                          <a:solidFill>
-                            <a:srgbClr val="22262B"/>
-                          </a:solidFill>
-                          <a:latin typeface="Calibri"/>
-                        </a:rPr>
-                        <a:t>Frozen VLM frame features + action-name text embeddings for 50S; build s (N×T); diagnostics</a:t>
-                      </a:r>
-                    </a:p>
-                  </a:txBody>
-                  <a:tcPr>
-                    <a:solidFill>
-                      <a:srgbClr val="ECEEF1"/>
-                    </a:solidFill>
-                  </a:tcPr>
-                </a:tc>
-                <a:tc>
-                  <a:txBody>
-                    <a:bodyPr/>
-                    <a:lstStyle/>
-                    <a:p>
-                      <a:r>
-                        <a:rPr sz="1050">
-                          <a:solidFill>
-                            <a:srgbClr val="22262B"/>
-                          </a:solidFill>
-                          <a:latin typeface="Calibri"/>
-                        </a:rPr>
-                        <a:t>raw video</a:t>
-                      </a:r>
-                    </a:p>
-                  </a:txBody>
-                  <a:tcPr>
-                    <a:solidFill>
-                      <a:srgbClr val="ECEEF1"/>
-                    </a:solidFill>
-                  </a:tcPr>
-                </a:tc>
-                <a:tc>
-                  <a:txBody>
-                    <a:bodyPr/>
-                    <a:lstStyle/>
-                    <a:p>
-                      <a:r>
-                        <a:rPr sz="1050">
-                          <a:solidFill>
-                            <a:srgbClr val="22262B"/>
-                          </a:solidFill>
-                          <a:latin typeface="Calibri"/>
-                        </a:rPr>
-                        <a:t>s; zero-shot confusion; boundary peakedness</a:t>
-                      </a:r>
-                    </a:p>
-                  </a:txBody>
-                  <a:tcPr>
-                    <a:solidFill>
-                      <a:srgbClr val="ECEEF1"/>
-                    </a:solidFill>
-                  </a:tcPr>
-                </a:tc>
-              </a:tr>
-              <a:tr h="365760">
-                <a:tc>
-                  <a:txBody>
-                    <a:bodyPr/>
-                    <a:lstStyle/>
-                    <a:p>
-                      <a:r>
-                        <a:rPr sz="1050">
-                          <a:solidFill>
-                            <a:srgbClr val="22262B"/>
-                          </a:solidFill>
-                          <a:latin typeface="Calibri"/>
-                        </a:rPr>
-                        <a:t>2</a:t>
-                      </a:r>
-                    </a:p>
-                  </a:txBody>
-                  <a:tcPr>
-                    <a:solidFill>
-                      <a:srgbClr val="FFFFFF"/>
-                    </a:solidFill>
-                  </a:tcPr>
-                </a:tc>
-                <a:tc>
-                  <a:txBody>
-                    <a:bodyPr/>
-                    <a:lstStyle/>
-                    <a:p>
-                      <a:r>
-                        <a:rPr sz="1050">
-                          <a:solidFill>
-                            <a:srgbClr val="22262B"/>
-                          </a:solidFill>
-                          <a:latin typeface="Calibri"/>
-                        </a:rPr>
-                        <a:t>Plug s into DELTA's alignment (wclot cost matrix ~1 line, or atba boundary detector)</a:t>
-                      </a:r>
-                    </a:p>
-                  </a:txBody>
-                  <a:tcPr>
-                    <a:solidFill>
-                      <a:srgbClr val="FFFFFF"/>
-                    </a:solidFill>
-                  </a:tcPr>
-                </a:tc>
-                <a:tc>
-                  <a:txBody>
-                    <a:bodyPr/>
-                    <a:lstStyle/>
-                    <a:p>
-                      <a:r>
-                        <a:rPr sz="1050">
-                          <a:solidFill>
-                            <a:srgbClr val="22262B"/>
-                          </a:solidFill>
-                          <a:latin typeface="Calibri"/>
-                        </a:rPr>
-                        <a:t>phase 1</a:t>
-                      </a:r>
-                    </a:p>
-                  </a:txBody>
-                  <a:tcPr>
-                    <a:solidFill>
-                      <a:srgbClr val="FFFFFF"/>
-                    </a:solidFill>
-                  </a:tcPr>
-                </a:tc>
-                <a:tc>
-                  <a:txBody>
-                    <a:bodyPr/>
-                    <a:lstStyle/>
-                    <a:p>
-                      <a:r>
-                        <a:rPr sz="1050">
-                          <a:solidFill>
-                            <a:srgbClr val="22262B"/>
-                          </a:solidFill>
-                          <a:latin typeface="Calibri"/>
-                        </a:rPr>
-                        <a:t>Y* quality vs ATBA / HAL / naive floor</a:t>
-                      </a:r>
-                    </a:p>
-                  </a:txBody>
-                  <a:tcPr>
-                    <a:solidFill>
-                      <a:srgbClr val="FFFFFF"/>
-                    </a:solidFill>
-                  </a:tcPr>
-                </a:tc>
-              </a:tr>
-              <a:tr h="365760">
-                <a:tc>
-                  <a:txBody>
-                    <a:bodyPr/>
-                    <a:lstStyle/>
-                    <a:p>
-                      <a:r>
-                        <a:rPr sz="1050">
-                          <a:solidFill>
-                            <a:srgbClr val="22262B"/>
-                          </a:solidFill>
-                          <a:latin typeface="Calibri"/>
-                        </a:rPr>
-                        <a:t>3</a:t>
-                      </a:r>
-                    </a:p>
-                  </a:txBody>
-                  <a:tcPr>
-                    <a:solidFill>
-                      <a:srgbClr val="ECEEF1"/>
-                    </a:solidFill>
-                  </a:tcPr>
-                </a:tc>
-                <a:tc>
-                  <a:txBody>
-                    <a:bodyPr/>
-                    <a:lstStyle/>
-                    <a:p>
-                      <a:r>
-                        <a:rPr sz="1050">
-                          <a:solidFill>
-                            <a:srgbClr val="22262B"/>
-                          </a:solidFill>
-                          <a:latin typeface="Calibri"/>
-                        </a:rPr>
-                        <a:t>Borrow from CVA: CBD boundary-contrastive loss on aligned boundaries; CTE-style encoder on VLM feats</a:t>
-                      </a:r>
-                    </a:p>
-                  </a:txBody>
-                  <a:tcPr>
-                    <a:solidFill>
-                      <a:srgbClr val="ECEEF1"/>
-                    </a:solidFill>
-                  </a:tcPr>
-                </a:tc>
-                <a:tc>
-                  <a:txBody>
-                    <a:bodyPr/>
-                    <a:lstStyle/>
-                    <a:p>
-                      <a:r>
-                        <a:rPr sz="1050">
-                          <a:solidFill>
-                            <a:srgbClr val="22262B"/>
-                          </a:solidFill>
-                          <a:latin typeface="Calibri"/>
-                        </a:rPr>
-                        <a:t>phase 2</a:t>
-                      </a:r>
-                    </a:p>
-                  </a:txBody>
-                  <a:tcPr>
-                    <a:solidFill>
-                      <a:srgbClr val="ECEEF1"/>
-                    </a:solidFill>
-                  </a:tcPr>
-                </a:tc>
-                <a:tc>
-                  <a:txBody>
-                    <a:bodyPr/>
-                    <a:lstStyle/>
-                    <a:p>
-                      <a:r>
-                        <a:rPr sz="1050">
-                          <a:solidFill>
-                            <a:srgbClr val="22262B"/>
-                          </a:solidFill>
-                          <a:latin typeface="Calibri"/>
-                        </a:rPr>
-                        <a:t>which CVA idea helps</a:t>
-                      </a:r>
-                    </a:p>
-                  </a:txBody>
-                  <a:tcPr>
-                    <a:solidFill>
-                      <a:srgbClr val="ECEEF1"/>
-                    </a:solidFill>
-                  </a:tcPr>
-                </a:tc>
-              </a:tr>
-              <a:tr h="365760">
-                <a:tc>
-                  <a:txBody>
-                    <a:bodyPr/>
-                    <a:lstStyle/>
-                    <a:p>
-                      <a:r>
-                        <a:rPr sz="1050">
-                          <a:solidFill>
-                            <a:srgbClr val="22262B"/>
-                          </a:solidFill>
-                          <a:latin typeface="Calibri"/>
-                        </a:rPr>
-                        <a:t>4</a:t>
-                      </a:r>
-                    </a:p>
-                  </a:txBody>
-                  <a:tcPr>
-                    <a:solidFill>
-                      <a:srgbClr val="FFFFFF"/>
-                    </a:solidFill>
-                  </a:tcPr>
-                </a:tc>
-                <a:tc>
-                  <a:txBody>
-                    <a:bodyPr/>
-                    <a:lstStyle/>
-                    <a:p>
-                      <a:r>
-                        <a:rPr sz="1050">
-                          <a:solidFill>
-                            <a:srgbClr val="22262B"/>
-                          </a:solidFill>
-                          <a:latin typeface="Calibri"/>
-                        </a:rPr>
-                        <a:t>Best Y* → DELTA decoder; Obs%/Pred% MoC grid</a:t>
-                      </a:r>
-                    </a:p>
-                  </a:txBody>
-                  <a:tcPr>
-                    <a:solidFill>
-                      <a:srgbClr val="FFFFFF"/>
-                    </a:solidFill>
-                  </a:tcPr>
-                </a:tc>
-                <a:tc>
-                  <a:txBody>
-                    <a:bodyPr/>
-                    <a:lstStyle/>
-                    <a:p>
-                      <a:r>
-                        <a:rPr sz="1050">
-                          <a:solidFill>
-                            <a:srgbClr val="22262B"/>
-                          </a:solidFill>
-                          <a:latin typeface="Calibri"/>
-                        </a:rPr>
-                        <a:t>phase 3</a:t>
-                      </a:r>
-                    </a:p>
-                  </a:txBody>
-                  <a:tcPr>
-                    <a:solidFill>
-                      <a:srgbClr val="FFFFFF"/>
-                    </a:solidFill>
-                  </a:tcPr>
-                </a:tc>
-                <a:tc>
-                  <a:txBody>
-                    <a:bodyPr/>
-                    <a:lstStyle/>
-                    <a:p>
-                      <a:r>
-                        <a:rPr sz="1050">
-                          <a:solidFill>
-                            <a:srgbClr val="22262B"/>
-                          </a:solidFill>
-                          <a:latin typeface="Calibri"/>
-                        </a:rPr>
-                        <a:t>the result vs ATBA / HAL / DELTA</a:t>
-                      </a:r>
-                    </a:p>
-                  </a:txBody>
-                  <a:tcPr>
-                    <a:solidFill>
-                      <a:srgbClr val="FFFFFF"/>
-                    </a:solidFill>
-                  </a:tcPr>
-                </a:tc>
-              </a:tr>
-            </a:tbl>
-          </a:graphicData>
-        </a:graphic>
-      </p:graphicFrame>
+        </p:nvSpPr>
+        <p:spPr>
+          <a:xfrm>
+            <a:off x="640080" y="1600200"/>
+            <a:ext cx="10972800" cy="4937760"/>
+          </a:xfrm>
+          <a:prstGeom prst="rect">
+            <a:avLst/>
+          </a:prstGeom>
+          <a:noFill/>
+        </p:spPr>
+        <p:txBody>
+          <a:bodyPr wrap="square">
+            <a:spAutoFit/>
+          </a:bodyPr>
+          <a:lstStyle/>
+          <a:p>
+            <a:pPr>
+              <a:spcAft>
+                <a:spcPts val="600"/>
+              </a:spcAft>
+            </a:pPr>
+            <a:r>
+              <a:rPr sz="1700" b="0">
+                <a:solidFill>
+                  <a:srgbClr val="22262B"/>
+                </a:solidFill>
+                <a:latin typeface="Calibri"/>
+              </a:rPr>
+              <a:t>▸ All work goes through the DELTA / WLTA code, which runs 50Salads natively (-d FS -c 19) with both alignment modes:</a:t>
+            </a:r>
+          </a:p>
+          <a:p>
+            <a:pPr lvl="1">
+              <a:spcAft>
+                <a:spcPts val="600"/>
+              </a:spcAft>
+            </a:pPr>
+            <a:r>
+              <a:rPr sz="1500">
+                <a:solidFill>
+                  <a:srgbClr val="5B6470"/>
+                </a:solidFill>
+                <a:latin typeface="Calibri"/>
+              </a:rPr>
+              <a:t>– --model_type atba  = ATBA-in-DELTA   (= our ATBA baseline on 50Salads)</a:t>
+            </a:r>
+          </a:p>
+          <a:p>
+            <a:pPr lvl="1">
+              <a:spcAft>
+                <a:spcPts val="600"/>
+              </a:spcAft>
+            </a:pPr>
+            <a:r>
+              <a:rPr sz="1500">
+                <a:solidFill>
+                  <a:srgbClr val="5B6470"/>
+                </a:solidFill>
+                <a:latin typeface="Calibri"/>
+              </a:rPr>
+              <a:t>– --model_type wclot = ASOT-in-DELTA   (optimal transport, already there)</a:t>
+            </a:r>
+          </a:p>
+          <a:p>
+            <a:pPr>
+              <a:spcAft>
+                <a:spcPts val="600"/>
+              </a:spcAft>
+            </a:pPr>
+            <a:r>
+              <a:rPr sz="1700" b="0">
+                <a:solidFill>
+                  <a:srgbClr val="22262B"/>
+                </a:solidFill>
+                <a:latin typeface="Calibri"/>
+              </a:rPr>
+              <a:t>▸ No Breakfast, no standalone HAL. HAL test = its losses ported into DELTA's atba path.</a:t>
+            </a:r>
+          </a:p>
+          <a:p>
+            <a:pPr>
+              <a:spcAft>
+                <a:spcPts val="600"/>
+              </a:spcAft>
+            </a:pPr>
+            <a:r>
+              <a:rPr sz="1700" b="0">
+                <a:solidFill>
+                  <a:srgbClr val="22262B"/>
+                </a:solidFill>
+                <a:latin typeface="Calibri"/>
+              </a:rPr>
+              <a:t>▸ Two tracks:</a:t>
+            </a:r>
+          </a:p>
+          <a:p>
+            <a:pPr lvl="1">
+              <a:spcAft>
+                <a:spcPts val="600"/>
+              </a:spcAft>
+            </a:pPr>
+            <a:r>
+              <a:rPr sz="1500">
+                <a:solidFill>
+                  <a:srgbClr val="5B6470"/>
+                </a:solidFill>
+                <a:latin typeface="Calibri"/>
+              </a:rPr>
+              <a:t>– HAL track (Eliz) — I3D features only, no raw video, runs NOW.</a:t>
+            </a:r>
+          </a:p>
+          <a:p>
+            <a:pPr lvl="1">
+              <a:spcAft>
+                <a:spcPts val="600"/>
+              </a:spcAft>
+            </a:pPr>
+            <a:r>
+              <a:rPr sz="1500">
+                <a:solidFill>
+                  <a:srgbClr val="5B6470"/>
+                </a:solidFill>
+                <a:latin typeface="Calibri"/>
+              </a:rPr>
+              <a:t>– VLM track (InternVideo2) — needs raw 50Salads video (still the blocker).</a:t>
+            </a:r>
+          </a:p>
+          <a:p>
+            <a:pPr>
+              <a:spcAft>
+                <a:spcPts val="600"/>
+              </a:spcAft>
+            </a:pPr>
+            <a:r>
+              <a:rPr sz="1700" b="0">
+                <a:solidFill>
+                  <a:srgbClr val="22262B"/>
+                </a:solidFill>
+                <a:latin typeface="Calibri"/>
+              </a:rPr>
+              <a:t>▸ Baselines: naive 0.34 MoC · ATBA-in-DELTA · ASOT-in-DELTA · HAL-in-DELTA.</a:t>
+            </a:r>
+          </a:p>
+        </p:txBody>
+      </p:sp>
     </p:spTree>
   </p:cSld>
   <p:clrMapOvr>
@@ -5586,7 +5185,7 @@
                 </a:solidFill>
                 <a:latin typeface="Calibri"/>
               </a:rPr>
-              <a:t>My workstream — HAL (H1–H7)</a:t>
+              <a:t>My workstream — HAL on 50Salads (H1–H7)</a:t>
             </a:r>
           </a:p>
           <a:p>
@@ -5597,7 +5196,7 @@
                 </a:solidFill>
                 <a:latin typeface="Calibri"/>
               </a:rPr>
-              <a:t>expected magnitude small — but it's the baseline table, and a clean negative is a real finding</a:t>
+              <a:t>I3D features only — no raw video needed. Expected magnitude small; a clean negative is still a finding.</a:t>
             </a:r>
           </a:p>
         </p:txBody>
@@ -5655,7 +5254,7 @@
         </p:nvGraphicFramePr>
         <p:xfrm>
           <a:off x="548640" y="1645920"/>
-          <a:ext cx="11064240" cy="2926080"/>
+          <a:ext cx="11064239" cy="2926080"/>
         </p:xfrm>
         <a:graphic>
           <a:graphicData uri="http://schemas.openxmlformats.org/drawingml/2006/table">
@@ -5664,9 +5263,9 @@
                 <a:tableStyleId>{5C22544A-7EE6-4342-B048-85BDC9FD1C3A}</a:tableStyleId>
               </a:tblPr>
               <a:tblGrid>
-                <a:gridCol w="548640"/>
-                <a:gridCol w="7315200"/>
-                <a:gridCol w="3200400"/>
+                <a:gridCol w="457200"/>
+                <a:gridCol w="7498079"/>
+                <a:gridCol w="3108960"/>
               </a:tblGrid>
               <a:tr h="365760">
                 <a:tc>
@@ -5675,7 +5274,7 @@
                     <a:lstStyle/>
                     <a:p>
                       <a:r>
-                        <a:rPr sz="1100" b="1">
+                        <a:rPr sz="1050" b="1">
                           <a:solidFill>
                             <a:srgbClr val="FFFFFF"/>
                           </a:solidFill>
@@ -5697,7 +5296,7 @@
                     <a:lstStyle/>
                     <a:p>
                       <a:r>
-                        <a:rPr sz="1100" b="1">
+                        <a:rPr sz="1050" b="1">
                           <a:solidFill>
                             <a:srgbClr val="FFFFFF"/>
                           </a:solidFill>
@@ -5719,7 +5318,7 @@
                     <a:lstStyle/>
                     <a:p>
                       <a:r>
-                        <a:rPr sz="1100" b="1">
+                        <a:rPr sz="1050" b="1">
                           <a:solidFill>
                             <a:srgbClr val="FFFFFF"/>
                           </a:solidFill>
@@ -5743,7 +5342,7 @@
                     <a:lstStyle/>
                     <a:p>
                       <a:r>
-                        <a:rPr sz="1000">
+                        <a:rPr sz="950">
                           <a:solidFill>
                             <a:srgbClr val="22262B"/>
                           </a:solidFill>
@@ -5765,13 +5364,13 @@
                     <a:lstStyle/>
                     <a:p>
                       <a:r>
-                        <a:rPr sz="1000">
+                        <a:rPr sz="950">
                           <a:solidFill>
                             <a:srgbClr val="22262B"/>
                           </a:solidFill>
                           <a:latin typeface="Calibri"/>
                         </a:rPr>
-                        <a:t>Env + Breakfast features; reproduce ATBA split 1</a:t>
+                        <a:t>Cluster env (Py3.9/torch1.11 conda); arrange data/FS/ from the dinggd/50salads bundle</a:t>
                       </a:r>
                     </a:p>
                   </a:txBody>
@@ -5787,13 +5386,13 @@
                     <a:lstStyle/>
                     <a:p>
                       <a:r>
-                        <a:rPr sz="1000">
+                        <a:rPr sz="950">
                           <a:solidFill>
                             <a:srgbClr val="22262B"/>
                           </a:solidFill>
                           <a:latin typeface="Calibri"/>
                         </a:rPr>
-                        <a:t>≈53.9 MoF — pipeline works</a:t>
+                        <a:t>data ready</a:t>
                       </a:r>
                     </a:p>
                   </a:txBody>
@@ -5811,7 +5410,7 @@
                     <a:lstStyle/>
                     <a:p>
                       <a:r>
-                        <a:rPr sz="1000">
+                        <a:rPr sz="950">
                           <a:solidFill>
                             <a:srgbClr val="22262B"/>
                           </a:solidFill>
@@ -5833,13 +5432,13 @@
                     <a:lstStyle/>
                     <a:p>
                       <a:r>
-                        <a:rPr sz="1000">
+                        <a:rPr sz="950">
                           <a:solidFill>
                             <a:srgbClr val="22262B"/>
                           </a:solidFill>
                           <a:latin typeface="Calibri"/>
                         </a:rPr>
-                        <a:t>Reproduce HAL split 1 (README command)</a:t>
+                        <a:t>Run WLTA train.py -d FS -c 19 --model_type atba (+ wclot) on 50S, ≥1 split</a:t>
                       </a:r>
                     </a:p>
                   </a:txBody>
@@ -5855,13 +5454,13 @@
                     <a:lstStyle/>
                     <a:p>
                       <a:r>
-                        <a:rPr sz="1000">
+                        <a:rPr sz="950">
                           <a:solidFill>
                             <a:srgbClr val="22262B"/>
                           </a:solidFill>
                           <a:latin typeface="Calibri"/>
                         </a:rPr>
-                        <a:t>≈56.3 MoF — HAL reproduces</a:t>
+                        <a:t>baseline: TAS MoF/MoC + Obs%/Pred% MoC</a:t>
                       </a:r>
                     </a:p>
                   </a:txBody>
@@ -5879,7 +5478,7 @@
                     <a:lstStyle/>
                     <a:p>
                       <a:r>
-                        <a:rPr sz="1000">
+                        <a:rPr sz="950">
                           <a:solidFill>
                             <a:srgbClr val="22262B"/>
                           </a:solidFill>
@@ -5901,13 +5500,13 @@
                     <a:lstStyle/>
                     <a:p>
                       <a:r>
-                        <a:rPr sz="1000">
+                        <a:rPr sz="950">
                           <a:solidFill>
                             <a:srgbClr val="22262B"/>
                           </a:solidFill>
                           <a:latin typeface="Calibri"/>
                         </a:rPr>
-                        <a:t>Dump ATBA pseudo-labels + z1/z2; score Y* with delta.align (MoC, edit, F1@k, boundary offset)</a:t>
+                        <a:t>Instrument the loop: dump tas_pseudolabels; score Y* vs GT with delta.align (MoC, edit, F1@k, boundary offset) vs the naive floor 0.34</a:t>
                       </a:r>
                     </a:p>
                   </a:txBody>
@@ -5923,13 +5522,13 @@
                     <a:lstStyle/>
                     <a:p>
                       <a:r>
-                        <a:rPr sz="1000">
+                        <a:rPr sz="950">
                           <a:solidFill>
                             <a:srgbClr val="22262B"/>
                           </a:solidFill>
                           <a:latin typeface="Calibri"/>
                         </a:rPr>
-                        <a:t>does HAL give better pseudo-labels, or only better final MoF?</a:t>
+                        <a:t>the pseudo-label number HAL must beat</a:t>
                       </a:r>
                     </a:p>
                   </a:txBody>
@@ -5947,7 +5546,7 @@
                     <a:lstStyle/>
                     <a:p>
                       <a:r>
-                        <a:rPr sz="1000">
+                        <a:rPr sz="950">
                           <a:solidFill>
                             <a:srgbClr val="22262B"/>
                           </a:solidFill>
@@ -5969,13 +5568,13 @@
                     <a:lstStyle/>
                     <a:p>
                       <a:r>
-                        <a:rPr sz="1000">
+                        <a:rPr sz="950">
                           <a:solidFill>
                             <a:srgbClr val="22262B"/>
                           </a:solidFill>
                           <a:latin typeface="Calibri"/>
                         </a:rPr>
-                        <a:t>Get HAL running on 50Salads (add config, splits, transcripts; widen loader assert)</a:t>
+                        <a:t>Port HAL into DELTA --model_type atba: VAE tap (z1 slow / z2 fast) + recon/kl/diff losses in atba_loss.py (~70 lines); warm_epc→40</a:t>
                       </a:r>
                     </a:p>
                   </a:txBody>
@@ -5991,13 +5590,13 @@
                     <a:lstStyle/>
                     <a:p>
                       <a:r>
-                        <a:rPr sz="1000">
+                        <a:rPr sz="950">
                           <a:solidFill>
                             <a:srgbClr val="22262B"/>
                           </a:solidFill>
                           <a:latin typeface="Calibri"/>
                         </a:rPr>
-                        <a:t>first HAL 50Salads number</a:t>
+                        <a:t>DELTA-atba+HAL</a:t>
                       </a:r>
                     </a:p>
                   </a:txBody>
@@ -6015,7 +5614,7 @@
                     <a:lstStyle/>
                     <a:p>
                       <a:r>
-                        <a:rPr sz="1000">
+                        <a:rPr sz="950">
                           <a:solidFill>
                             <a:srgbClr val="22262B"/>
                           </a:solidFill>
@@ -6037,13 +5636,13 @@
                     <a:lstStyle/>
                     <a:p>
                       <a:r>
-                        <a:rPr sz="1000">
+                        <a:rPr sz="950">
                           <a:solidFill>
                             <a:srgbClr val="22262B"/>
                           </a:solidFill>
                           <a:latin typeface="Calibri"/>
                         </a:rPr>
-                        <a:t>Port HAL into DELTA — VAE tap + recon/kl/diff losses on --model_type atba (~70 lines)</a:t>
+                        <a:t>Run DELTA-atba+HAL on 50S → compare Y* quality (vs H3) and Obs%/Pred% MoC (vs H2)</a:t>
                       </a:r>
                     </a:p>
                   </a:txBody>
@@ -6059,13 +5658,13 @@
                     <a:lstStyle/>
                     <a:p>
                       <a:r>
-                        <a:rPr sz="1000">
+                        <a:rPr sz="950">
                           <a:solidFill>
                             <a:srgbClr val="22262B"/>
                           </a:solidFill>
                           <a:latin typeface="Calibri"/>
                         </a:rPr>
-                        <a:t>DELTA-atba+HAL</a:t>
+                        <a:t>does HAL's prior transfer to DLTA?</a:t>
                       </a:r>
                     </a:p>
                   </a:txBody>
@@ -6083,7 +5682,7 @@
                     <a:lstStyle/>
                     <a:p>
                       <a:r>
-                        <a:rPr sz="1000">
+                        <a:rPr sz="950">
                           <a:solidFill>
                             <a:srgbClr val="22262B"/>
                           </a:solidFill>
@@ -6105,13 +5704,13 @@
                     <a:lstStyle/>
                     <a:p>
                       <a:r>
-                        <a:rPr sz="1000">
+                        <a:rPr sz="950">
                           <a:solidFill>
                             <a:srgbClr val="22262B"/>
                           </a:solidFill>
                           <a:latin typeface="Calibri"/>
                         </a:rPr>
-                        <a:t>DELTA-atba vs DELTA-atba+HAL on 50S + Breakfast → Obs%/Pred% MoC; ablate the 3 terms</a:t>
+                        <a:t>Ablate: recon-only / kl-only / diff-only / warm_epc</a:t>
                       </a:r>
                     </a:p>
                   </a:txBody>
@@ -6127,13 +5726,13 @@
                     <a:lstStyle/>
                     <a:p>
                       <a:r>
-                        <a:rPr sz="1000">
+                        <a:rPr sz="950">
                           <a:solidFill>
                             <a:srgbClr val="22262B"/>
                           </a:solidFill>
                           <a:latin typeface="Calibri"/>
                         </a:rPr>
-                        <a:t>the result (+ or −)</a:t>
+                        <a:t>which term matters</a:t>
                       </a:r>
                     </a:p>
                   </a:txBody>
@@ -6151,7 +5750,7 @@
                     <a:lstStyle/>
                     <a:p>
                       <a:r>
-                        <a:rPr sz="1000">
+                        <a:rPr sz="950">
                           <a:solidFill>
                             <a:srgbClr val="22262B"/>
                           </a:solidFill>
@@ -6173,13 +5772,13 @@
                     <a:lstStyle/>
                     <a:p>
                       <a:r>
-                        <a:rPr sz="1000">
+                        <a:rPr sz="950">
                           <a:solidFill>
                             <a:srgbClr val="22262B"/>
                           </a:solidFill>
                           <a:latin typeface="Calibri"/>
                         </a:rPr>
-                        <a:t>If diff_loss (smoothness) helps → hand it to the VLM-aligner workstream</a:t>
+                        <a:t>If diff_loss (smoothness) helps → hand the change-rate penalty to the VLM-aligner track</a:t>
                       </a:r>
                     </a:p>
                   </a:txBody>
@@ -6195,7 +5794,7 @@
                     <a:lstStyle/>
                     <a:p>
                       <a:r>
-                        <a:rPr sz="1000">
+                        <a:rPr sz="950">
                           <a:solidFill>
                             <a:srgbClr val="22262B"/>
                           </a:solidFill>
@@ -6271,7 +5870,7 @@
                 </a:solidFill>
                 <a:latin typeface="Calibri"/>
               </a:rPr>
-              <a:t>The DELTA VLM-direct method (where both workstreams land)</a:t>
+              <a:t>The VLM-direct method — InternVideo2 (V1–V6)</a:t>
             </a:r>
           </a:p>
           <a:p>
@@ -6282,7 +5881,7 @@
                 </a:solidFill>
                 <a:latin typeface="Calibri"/>
               </a:rPr>
-              <a:t>frozen VLM similarity → alignment → DELTA  ·  regularised by CVA + HAL ideas</a:t>
+              <a:t>frozen InternVideo2 similarity → alignment → DELTA  ·  + CVA (CBD/CTE) + HAL (smoothness)</a:t>
             </a:r>
           </a:p>
         </p:txBody>
@@ -6364,7 +5963,7 @@
                 </a:solidFill>
                 <a:latin typeface="Calibri"/>
               </a:rPr>
-              <a:t>▸ s(n,t) = sim( VLM_text(action_n), VLM_frame_t )  — frozen; no frame classifier in the alignment path.</a:t>
+              <a:t>▸ s(n,t) = cos( InternVideo2_text(action_n), InternVideo2_video(clip_t) )  — frozen, video-native (&gt; CVA's SlowFast + frame-CLIP for fine-grained / temporal). No frame classifier.</a:t>
             </a:r>
           </a:p>
           <a:p>
@@ -6380,7 +5979,7 @@
                 </a:solidFill>
                 <a:latin typeface="Calibri"/>
               </a:rPr>
-              <a:t>▸ Y* = order-preserving DP / optimal-transport alignment on s  (ASOT is already in DELTA).</a:t>
+              <a:t>▸ V1  add an internvideo2 backbone to delta.features.backbones   (~40 lines, can do now)</a:t>
             </a:r>
           </a:p>
           <a:p>
@@ -6396,7 +5995,7 @@
                 </a:solidFill>
                 <a:latin typeface="Calibri"/>
               </a:rPr>
-              <a:t>▸ + from CVA:  a CBD-style boundary-contrastive loss on the aligned boundary frames;  a CTE-style windowed + cross-attn encoder on the VLM features.</a:t>
+              <a:t>▸ V2–V3  extract InternVideo2 video + text features for 50S → build s → diagnostics (zero-shot confusion, boundary peakedness vs I3D's 1.11×)   [needs raw video]</a:t>
             </a:r>
           </a:p>
           <a:p>
@@ -6412,7 +6011,7 @@
                 </a:solidFill>
                 <a:latin typeface="Calibri"/>
               </a:rPr>
-              <a:t>▸ + from HAL:  the L_s change-rate / smoothness penalty on the soft assignment sequence  (anti over-segmentation, cheaper than HAL's VAE).</a:t>
+              <a:t>▸ V4  swap s into DELTA's alignment — wclot cost matrix (train.py:548, ~1 line) or atba BoundaryDetector</a:t>
             </a:r>
           </a:p>
           <a:p>
@@ -6428,7 +6027,7 @@
                 </a:solidFill>
                 <a:latin typeface="Calibri"/>
               </a:rPr>
-              <a:t>▸ Feed Y* into DELTA's decoder + CRF + duration head (unchanged) → Obs%/Pred% MoC.</a:t>
+              <a:t>▸ V5  + CVA's CBD boundary-contrastive loss on the aligned boundaries; + a CTE-style encoder</a:t>
             </a:r>
           </a:p>
           <a:p>
@@ -6444,7 +6043,23 @@
                 </a:solidFill>
                 <a:latin typeface="Calibri"/>
               </a:rPr>
-              <a:t>▸ Baselines: naive 0.34 · ATBA-in-DELTA · ASOT-in-DELTA · HAL · warm-up-classifier ceiling.</a:t>
+              <a:t>▸ V6  best Y* → DELTA decoder + CRF + duration head (unchanged) → Obs%/Pred% MoC on 50Salads</a:t>
+            </a:r>
+          </a:p>
+          <a:p>
+            <a:pPr>
+              <a:spcAft>
+                <a:spcPts val="600"/>
+              </a:spcAft>
+            </a:pPr>
+            <a:r>
+              <a:rPr sz="1700" b="0">
+                <a:solidFill>
+                  <a:srgbClr val="22262B"/>
+                </a:solidFill>
+                <a:latin typeface="Calibri"/>
+              </a:rPr>
+              <a:t>▸ + from HAL: the L_s smoothness penalty on the soft assignment (if H7 shows it helps).</a:t>
             </a:r>
           </a:p>
         </p:txBody>
@@ -6504,7 +6119,7 @@
                 </a:solidFill>
                 <a:latin typeface="Calibri"/>
               </a:rPr>
-              <a:t>Sequencing</a:t>
+              <a:t>Sequencing — two tracks, 50Salads only</a:t>
             </a:r>
           </a:p>
           <a:p>
@@ -6515,7 +6130,7 @@
                 </a:solidFill>
                 <a:latin typeface="Calibri"/>
               </a:rPr>
-              <a:t>two parallel tracks converging on the DELTA VLM-direct method</a:t>
+              <a:t>the HAL track has no blocker and starts immediately</a:t>
             </a:r>
           </a:p>
         </p:txBody>
@@ -6573,7 +6188,7 @@
         </p:nvGraphicFramePr>
         <p:xfrm>
           <a:off x="548640" y="1645920"/>
-          <a:ext cx="11064240" cy="1828800"/>
+          <a:ext cx="11064240" cy="2194560"/>
         </p:xfrm>
         <a:graphic>
           <a:graphicData uri="http://schemas.openxmlformats.org/drawingml/2006/table">
@@ -6582,10 +6197,9 @@
                 <a:tableStyleId>{5C22544A-7EE6-4342-B048-85BDC9FD1C3A}</a:tableStyleId>
               </a:tblPr>
               <a:tblGrid>
-                <a:gridCol w="914400"/>
-                <a:gridCol w="3566160"/>
-                <a:gridCol w="3566160"/>
-                <a:gridCol w="3017520"/>
+                <a:gridCol w="1005840"/>
+                <a:gridCol w="5120640"/>
+                <a:gridCol w="4937760"/>
               </a:tblGrid>
               <a:tr h="365760">
                 <a:tc>
@@ -6622,7 +6236,7 @@
                           </a:solidFill>
                           <a:latin typeface="Calibri"/>
                         </a:rPr>
-                        <a:t>Eliz (HAL)</a:t>
+                        <a:t>HAL track — Eliz (no raw video)</a:t>
                       </a:r>
                     </a:p>
                   </a:txBody>
@@ -6644,29 +6258,7 @@
                           </a:solidFill>
                           <a:latin typeface="Calibri"/>
                         </a:rPr>
-                        <a:t>Co-intern (CVA)</a:t>
-                      </a:r>
-                    </a:p>
-                  </a:txBody>
-                  <a:tcPr>
-                    <a:solidFill>
-                      <a:srgbClr val="1F3A5F"/>
-                    </a:solidFill>
-                  </a:tcPr>
-                </a:tc>
-                <a:tc>
-                  <a:txBody>
-                    <a:bodyPr/>
-                    <a:lstStyle/>
-                    <a:p>
-                      <a:r>
-                        <a:rPr sz="1050" b="1">
-                          <a:solidFill>
-                            <a:srgbClr val="FFFFFF"/>
-                          </a:solidFill>
-                          <a:latin typeface="Calibri"/>
-                        </a:rPr>
-                        <a:t>Shared</a:t>
+                        <a:t>VLM track (needs raw video)</a:t>
                       </a:r>
                     </a:p>
                   </a:txBody>
@@ -6712,7 +6304,7 @@
                           </a:solidFill>
                           <a:latin typeface="Calibri"/>
                         </a:rPr>
-                        <a:t>H1–H2: reproduce ATBA + HAL on Breakfast (cluster)</a:t>
+                        <a:t>H1–H2: WLTA env; run --model_type atba + wclot on 50S → baseline MoC</a:t>
                       </a:r>
                     </a:p>
                   </a:txBody>
@@ -6734,29 +6326,7 @@
                           </a:solidFill>
                           <a:latin typeface="Calibri"/>
                         </a:rPr>
-                        <a:t>read CVA code; reproduce on QVHighlights</a:t>
-                      </a:r>
-                    </a:p>
-                  </a:txBody>
-                  <a:tcPr>
-                    <a:solidFill>
-                      <a:srgbClr val="FFFFFF"/>
-                    </a:solidFill>
-                  </a:tcPr>
-                </a:tc>
-                <a:tc>
-                  <a:txBody>
-                    <a:bodyPr/>
-                    <a:lstStyle/>
-                    <a:p>
-                      <a:r>
-                        <a:rPr sz="950">
-                          <a:solidFill>
-                            <a:srgbClr val="22262B"/>
-                          </a:solidFill>
-                          <a:latin typeface="Calibri"/>
-                        </a:rPr>
-                        <a:t>chase raw 50S video</a:t>
+                        <a:t>V1: add the internvideo2 backbone</a:t>
                       </a:r>
                     </a:p>
                   </a:txBody>
@@ -6780,7 +6350,7 @@
                           </a:solidFill>
                           <a:latin typeface="Calibri"/>
                         </a:rPr>
-                        <a:t>Wk 1–2</a:t>
+                        <a:t>+1–2 wk</a:t>
                       </a:r>
                     </a:p>
                   </a:txBody>
@@ -6802,7 +6372,7 @@
                           </a:solidFill>
                           <a:latin typeface="Calibri"/>
                         </a:rPr>
-                        <a:t>H3–H4: score pseudo-labels; HAL on 50Salads</a:t>
+                        <a:t>H3: dump pseudo-labels; score Y* vs the naive floor</a:t>
                       </a:r>
                     </a:p>
                   </a:txBody>
@@ -6824,29 +6394,7 @@
                           </a:solidFill>
                           <a:latin typeface="Calibri"/>
                         </a:rPr>
-                        <a:t>isolate CBD + CTE as reusable modules</a:t>
-                      </a:r>
-                    </a:p>
-                  </a:txBody>
-                  <a:tcPr>
-                    <a:solidFill>
-                      <a:srgbClr val="ECEEF1"/>
-                    </a:solidFill>
-                  </a:tcPr>
-                </a:tc>
-                <a:tc>
-                  <a:txBody>
-                    <a:bodyPr/>
-                    <a:lstStyle/>
-                    <a:p>
-                      <a:r>
-                        <a:rPr sz="950">
-                          <a:solidFill>
-                            <a:srgbClr val="22262B"/>
-                          </a:solidFill>
-                          <a:latin typeface="Calibri"/>
-                        </a:rPr>
-                        <a:t>phase 0: DELTA/WLTA baselines</a:t>
+                        <a:t>chase raw 50S video from the lab</a:t>
                       </a:r>
                     </a:p>
                   </a:txBody>
@@ -6870,7 +6418,7 @@
                           </a:solidFill>
                           <a:latin typeface="Calibri"/>
                         </a:rPr>
-                        <a:t>Wk 3–4</a:t>
+                        <a:t>+2–3 wk</a:t>
                       </a:r>
                     </a:p>
                   </a:txBody>
@@ -6892,7 +6440,7 @@
                           </a:solidFill>
                           <a:latin typeface="Calibri"/>
                         </a:rPr>
-                        <a:t>H5–H6: HAL in DELTA; MoC ablation</a:t>
+                        <a:t>H4–H5: port HAL into DELTA-atba; compare Y* + Obs%/Pred% MoC</a:t>
                       </a:r>
                     </a:p>
                   </a:txBody>
@@ -6914,29 +6462,7 @@
                           </a:solidFill>
                           <a:latin typeface="Calibri"/>
                         </a:rPr>
-                        <a:t>CBD/CTE on our VLM features (once video)</a:t>
-                      </a:r>
-                    </a:p>
-                  </a:txBody>
-                  <a:tcPr>
-                    <a:solidFill>
-                      <a:srgbClr val="FFFFFF"/>
-                    </a:solidFill>
-                  </a:tcPr>
-                </a:tc>
-                <a:tc>
-                  <a:txBody>
-                    <a:bodyPr/>
-                    <a:lstStyle/>
-                    <a:p>
-                      <a:r>
-                        <a:rPr sz="950">
-                          <a:solidFill>
-                            <a:srgbClr val="22262B"/>
-                          </a:solidFill>
-                          <a:latin typeface="Calibri"/>
-                        </a:rPr>
-                        <a:t>phase 1: VLM s for 50S</a:t>
+                        <a:t>V2–V3: InternVideo2 extraction; build s; diagnostics</a:t>
                       </a:r>
                     </a:p>
                   </a:txBody>
@@ -6960,7 +6486,7 @@
                           </a:solidFill>
                           <a:latin typeface="Calibri"/>
                         </a:rPr>
-                        <a:t>Wk 4+</a:t>
+                        <a:t>+3–4 wk</a:t>
                       </a:r>
                     </a:p>
                   </a:txBody>
@@ -6982,7 +6508,7 @@
                           </a:solidFill>
                           <a:latin typeface="Calibri"/>
                         </a:rPr>
-                        <a:t>H7: smoothness term → VLM aligner</a:t>
+                        <a:t>H6–H7: ablate; hand diff_loss to the VLM track</a:t>
                       </a:r>
                     </a:p>
                   </a:txBody>
@@ -7004,7 +6530,7 @@
                           </a:solidFill>
                           <a:latin typeface="Calibri"/>
                         </a:rPr>
-                        <a:t>CBD/CTE → VLM aligner</a:t>
+                        <a:t>V4: swap s into DELTA's alignment; score Y*</a:t>
                       </a:r>
                     </a:p>
                   </a:txBody>
@@ -7014,6 +6540,8 @@
                     </a:solidFill>
                   </a:tcPr>
                 </a:tc>
+              </a:tr>
+              <a:tr h="365760">
                 <a:tc>
                   <a:txBody>
                     <a:bodyPr/>
@@ -7026,13 +6554,57 @@
                           </a:solidFill>
                           <a:latin typeface="Calibri"/>
                         </a:rPr>
-                        <a:t>phases 2–4: VLM-direct alignment → DLTA MoC</a:t>
+                        <a:t>later</a:t>
                       </a:r>
                     </a:p>
                   </a:txBody>
                   <a:tcPr>
                     <a:solidFill>
-                      <a:srgbClr val="ECEEF1"/>
+                      <a:srgbClr val="FFFFFF"/>
+                    </a:solidFill>
+                  </a:tcPr>
+                </a:tc>
+                <a:tc>
+                  <a:txBody>
+                    <a:bodyPr/>
+                    <a:lstStyle/>
+                    <a:p>
+                      <a:r>
+                        <a:rPr sz="950">
+                          <a:solidFill>
+                            <a:srgbClr val="22262B"/>
+                          </a:solidFill>
+                          <a:latin typeface="Calibri"/>
+                        </a:rPr>
+                        <a:t>—</a:t>
+                      </a:r>
+                    </a:p>
+                  </a:txBody>
+                  <a:tcPr>
+                    <a:solidFill>
+                      <a:srgbClr val="FFFFFF"/>
+                    </a:solidFill>
+                  </a:tcPr>
+                </a:tc>
+                <a:tc>
+                  <a:txBody>
+                    <a:bodyPr/>
+                    <a:lstStyle/>
+                    <a:p>
+                      <a:r>
+                        <a:rPr sz="950">
+                          <a:solidFill>
+                            <a:srgbClr val="22262B"/>
+                          </a:solidFill>
+                          <a:latin typeface="Calibri"/>
+                        </a:rPr>
+                        <a:t>V5–V6: + CVA CBD/CTE; downstream Obs%/Pred% MoC</a:t>
+                      </a:r>
+                    </a:p>
+                  </a:txBody>
+                  <a:tcPr>
+                    <a:solidFill>
+                      <a:srgbClr val="FFFFFF"/>
                     </a:solidFill>
                   </a:tcPr>
                 </a:tc>

</xml_diff>

<commit_message>
Pivot HAL -> MASRA in progress deck and baselines doc
Supervisor requires a VLM-based TA with no segmentation-based approach, so
HAL is dropped as a workstream (kept as a baseline number only). New split:
Eliz -> MASRA (MLLM train-time LRCA/ESTA regulariser on InternVideo2
transcript x frame similarity, plan M1-M7), co-intern -> CVA.

- slides/make_deck.py + .pptx: 21 slides reworked for the pivot (framing,
  VLM-alignment literature, workstream split, MASRA M1-M7 plan, sequencing,
  questions).
- docs/baselines-hal-cva.md: scope-update banner, MASRA analysis section,
  genuine transcript->video aligner refs, rewritten workstream split; old
  HAL plan retained as record-only.
</commit_message>
<xml_diff>
--- a/slides/DELTA_progress_Mariella.pptx
+++ b/slides/DELTA_progress_Mariella.pptx
@@ -3326,7 +3326,7 @@
                 </a:solidFill>
                 <a:latin typeface="Calibri"/>
               </a:rPr>
-              <a:t>Progress 5 — HAL (CVPR'26), my focus</a:t>
+              <a:t>Progress 5 — VLM-alignment literature (analysed)</a:t>
             </a:r>
           </a:p>
           <a:p>
@@ -3337,7 +3337,7 @@
                 </a:solidFill>
                 <a:latin typeface="Calibri"/>
               </a:rPr>
-              <a:t>ATBA + a hierarchy/smoothness prior  ·  same task as us</a:t>
+              <a:t>no single paper = {weak supervision} × {VLM alignment} × {long-term anticipation}  →  that is the contribution</a:t>
             </a:r>
           </a:p>
         </p:txBody>
@@ -3385,141 +3385,574 @@
           </a:p>
         </p:txBody>
       </p:sp>
-      <p:sp>
-        <p:nvSpPr>
-          <p:cNvPr id="4" name="TextBox 3"/>
-          <p:cNvSpPr txBox="1"/>
+      <p:graphicFrame>
+        <p:nvGraphicFramePr>
+          <p:cNvPr id="4" name="Table 3"/>
+          <p:cNvGraphicFramePr>
+            <a:graphicFrameLocks noGrp="1"/>
+          </p:cNvGraphicFramePr>
           <p:nvPr/>
-        </p:nvSpPr>
-        <p:spPr>
-          <a:xfrm>
-            <a:off x="640080" y="1600200"/>
-            <a:ext cx="10972800" cy="4937760"/>
-          </a:xfrm>
-          <a:prstGeom prst="rect">
-            <a:avLst/>
-          </a:prstGeom>
-          <a:noFill/>
-        </p:spPr>
-        <p:txBody>
-          <a:bodyPr wrap="square">
-            <a:spAutoFit/>
-          </a:bodyPr>
-          <a:lstStyle/>
-          <a:p>
-            <a:pPr>
-              <a:spcAft>
-                <a:spcPts val="600"/>
-              </a:spcAft>
-            </a:pPr>
-            <a:r>
-              <a:rPr sz="1700" b="0">
-                <a:solidFill>
-                  <a:srgbClr val="22262B"/>
-                </a:solidFill>
-                <a:latin typeface="Calibri"/>
-              </a:rPr>
-              <a:t>▸ HAL = Hierarchical Action Learning. Verdict (confirmed from the CVPR PDF): HAL is NOT a different TA — it IS ATBA plus a small variational regulariser.</a:t>
-            </a:r>
-          </a:p>
-          <a:p>
-            <a:pPr lvl="1">
-              <a:spcAft>
-                <a:spcPts val="600"/>
-              </a:spcAft>
-            </a:pPr>
-            <a:r>
-              <a:rPr sz="1500">
-                <a:solidFill>
-                  <a:srgbClr val="5B6470"/>
-                </a:solidFill>
-                <a:latin typeface="Calibri"/>
-              </a:rPr>
-              <a:t>– models/model.py: "adapted from CVPR24_ATBA". Boundary detector = byte-for-byte ATBA.</a:t>
-            </a:r>
-          </a:p>
-          <a:p>
-            <a:pPr lvl="1">
-              <a:spcAft>
-                <a:spcPts val="600"/>
-              </a:spcAft>
-            </a:pPr>
-            <a:r>
-              <a:rPr sz="1500">
-                <a:solidFill>
-                  <a:srgbClr val="5B6470"/>
-                </a:solidFill>
-                <a:latin typeface="Calibri"/>
-              </a:rPr>
-              <a:t>– L_total = L_y^ATBA  −  α·ELBO  +  β·L_s</a:t>
-            </a:r>
-          </a:p>
-          <a:p>
-            <a:pPr lvl="1">
-              <a:spcAft>
-                <a:spcPts val="600"/>
-              </a:spcAft>
-            </a:pPr>
-            <a:r>
-              <a:rPr sz="1500">
-                <a:solidFill>
-                  <a:srgbClr val="5B6470"/>
-                </a:solidFill>
-                <a:latin typeface="Calibri"/>
-              </a:rPr>
-              <a:t>– ELBO = VAE reconstruction + KL on a two-scale latent (slow "action" z1 / fast "visual" z2); L_s = a change-rate penalty forcing z1 to evolve slower than z2.</a:t>
-            </a:r>
-          </a:p>
-          <a:p>
-            <a:pPr>
-              <a:spcAft>
-                <a:spcPts val="600"/>
-              </a:spcAft>
-            </a:pPr>
-            <a:r>
-              <a:rPr sz="1700" b="0">
-                <a:solidFill>
-                  <a:srgbClr val="22262B"/>
-                </a:solidFill>
-                <a:latin typeface="Calibri"/>
-              </a:rPr>
-              <a:t>▸ Gains over ATBA: +2.4 MoF Breakfast, +3.3 Hollywood, +3.0 GTEA — modest, some within std.</a:t>
-            </a:r>
-          </a:p>
-          <a:p>
-            <a:pPr>
-              <a:spcAft>
-                <a:spcPts val="600"/>
-              </a:spcAft>
-            </a:pPr>
-            <a:r>
-              <a:rPr sz="1700" b="0">
-                <a:solidFill>
-                  <a:srgbClr val="22262B"/>
-                </a:solidFill>
-                <a:latin typeface="Calibri"/>
-              </a:rPr>
-              <a:t>▸ Never evaluated 50Salads (loader rejects it). Reports MoF/IoU only — no edit, F1, boundary metric.</a:t>
-            </a:r>
-          </a:p>
-          <a:p>
-            <a:pPr>
-              <a:spcAft>
-                <a:spcPts val="600"/>
-              </a:spcAft>
-            </a:pPr>
-            <a:r>
-              <a:rPr sz="1700" b="0">
-                <a:solidFill>
-                  <a:srgbClr val="22262B"/>
-                </a:solidFill>
-                <a:latin typeface="Calibri"/>
-              </a:rPr>
-              <a:t>▸ Open question nobody has answered: does HAL's hierarchy + smoothness help dense anticipation (MoC), or only segmentation (MoF)?  ← my workstream.</a:t>
-            </a:r>
-          </a:p>
-        </p:txBody>
-      </p:sp>
+        </p:nvGraphicFramePr>
+        <p:xfrm>
+          <a:off x="548640" y="1645920"/>
+          <a:ext cx="11064240" cy="2194560"/>
+        </p:xfrm>
+        <a:graphic>
+          <a:graphicData uri="http://schemas.openxmlformats.org/drawingml/2006/table">
+            <a:tbl>
+              <a:tblPr firstRow="1" bandRow="1">
+                <a:tableStyleId>{5C22544A-7EE6-4342-B048-85BDC9FD1C3A}</a:tableStyleId>
+              </a:tblPr>
+              <a:tblGrid>
+                <a:gridCol w="1737360"/>
+                <a:gridCol w="914400"/>
+                <a:gridCol w="5760720"/>
+                <a:gridCol w="2651760"/>
+              </a:tblGrid>
+              <a:tr h="365760">
+                <a:tc>
+                  <a:txBody>
+                    <a:bodyPr/>
+                    <a:lstStyle/>
+                    <a:p>
+                      <a:r>
+                        <a:rPr sz="1050" b="1">
+                          <a:solidFill>
+                            <a:srgbClr val="FFFFFF"/>
+                          </a:solidFill>
+                          <a:latin typeface="Calibri"/>
+                        </a:rPr>
+                        <a:t>Paper</a:t>
+                      </a:r>
+                    </a:p>
+                  </a:txBody>
+                  <a:tcPr>
+                    <a:solidFill>
+                      <a:srgbClr val="1F3A5F"/>
+                    </a:solidFill>
+                  </a:tcPr>
+                </a:tc>
+                <a:tc>
+                  <a:txBody>
+                    <a:bodyPr/>
+                    <a:lstStyle/>
+                    <a:p>
+                      <a:r>
+                        <a:rPr sz="1050" b="1">
+                          <a:solidFill>
+                            <a:srgbClr val="FFFFFF"/>
+                          </a:solidFill>
+                          <a:latin typeface="Calibri"/>
+                        </a:rPr>
+                        <a:t>Venue</a:t>
+                      </a:r>
+                    </a:p>
+                  </a:txBody>
+                  <a:tcPr>
+                    <a:solidFill>
+                      <a:srgbClr val="1F3A5F"/>
+                    </a:solidFill>
+                  </a:tcPr>
+                </a:tc>
+                <a:tc>
+                  <a:txBody>
+                    <a:bodyPr/>
+                    <a:lstStyle/>
+                    <a:p>
+                      <a:r>
+                        <a:rPr sz="1050" b="1">
+                          <a:solidFill>
+                            <a:srgbClr val="FFFFFF"/>
+                          </a:solidFill>
+                          <a:latin typeface="Calibri"/>
+                        </a:rPr>
+                        <a:t>What it is</a:t>
+                      </a:r>
+                    </a:p>
+                  </a:txBody>
+                  <a:tcPr>
+                    <a:solidFill>
+                      <a:srgbClr val="1F3A5F"/>
+                    </a:solidFill>
+                  </a:tcPr>
+                </a:tc>
+                <a:tc>
+                  <a:txBody>
+                    <a:bodyPr/>
+                    <a:lstStyle/>
+                    <a:p>
+                      <a:r>
+                        <a:rPr sz="1050" b="1">
+                          <a:solidFill>
+                            <a:srgbClr val="FFFFFF"/>
+                          </a:solidFill>
+                          <a:latin typeface="Calibri"/>
+                        </a:rPr>
+                        <a:t>Role for us</a:t>
+                      </a:r>
+                    </a:p>
+                  </a:txBody>
+                  <a:tcPr>
+                    <a:solidFill>
+                      <a:srgbClr val="1F3A5F"/>
+                    </a:solidFill>
+                  </a:tcPr>
+                </a:tc>
+              </a:tr>
+              <a:tr h="365760">
+                <a:tc>
+                  <a:txBody>
+                    <a:bodyPr/>
+                    <a:lstStyle/>
+                    <a:p>
+                      <a:r>
+                        <a:rPr sz="950">
+                          <a:solidFill>
+                            <a:srgbClr val="22262B"/>
+                          </a:solidFill>
+                          <a:latin typeface="Calibri"/>
+                        </a:rPr>
+                        <a:t>ATBA</a:t>
+                      </a:r>
+                    </a:p>
+                  </a:txBody>
+                  <a:tcPr>
+                    <a:solidFill>
+                      <a:srgbClr val="FFFFFF"/>
+                    </a:solidFill>
+                  </a:tcPr>
+                </a:tc>
+                <a:tc>
+                  <a:txBody>
+                    <a:bodyPr/>
+                    <a:lstStyle/>
+                    <a:p>
+                      <a:r>
+                        <a:rPr sz="950">
+                          <a:solidFill>
+                            <a:srgbClr val="22262B"/>
+                          </a:solidFill>
+                          <a:latin typeface="Calibri"/>
+                        </a:rPr>
+                        <a:t>CVPR'24</a:t>
+                      </a:r>
+                    </a:p>
+                  </a:txBody>
+                  <a:tcPr>
+                    <a:solidFill>
+                      <a:srgbClr val="FFFFFF"/>
+                    </a:solidFill>
+                  </a:tcPr>
+                </a:tc>
+                <a:tc>
+                  <a:txBody>
+                    <a:bodyPr/>
+                    <a:lstStyle/>
+                    <a:p>
+                      <a:r>
+                        <a:rPr sz="950">
+                          <a:solidFill>
+                            <a:srgbClr val="22262B"/>
+                          </a:solidFill>
+                          <a:latin typeface="Calibri"/>
+                        </a:rPr>
+                        <a:t>the classifier→DP alignment DELTA's TA follows</a:t>
+                      </a:r>
+                    </a:p>
+                  </a:txBody>
+                  <a:tcPr>
+                    <a:solidFill>
+                      <a:srgbClr val="FFFFFF"/>
+                    </a:solidFill>
+                  </a:tcPr>
+                </a:tc>
+                <a:tc>
+                  <a:txBody>
+                    <a:bodyPr/>
+                    <a:lstStyle/>
+                    <a:p>
+                      <a:r>
+                        <a:rPr sz="950">
+                          <a:solidFill>
+                            <a:srgbClr val="22262B"/>
+                          </a:solidFill>
+                          <a:latin typeface="Calibri"/>
+                        </a:rPr>
+                        <a:t>the baseline we replace</a:t>
+                      </a:r>
+                    </a:p>
+                  </a:txBody>
+                  <a:tcPr>
+                    <a:solidFill>
+                      <a:srgbClr val="FFFFFF"/>
+                    </a:solidFill>
+                  </a:tcPr>
+                </a:tc>
+              </a:tr>
+              <a:tr h="365760">
+                <a:tc>
+                  <a:txBody>
+                    <a:bodyPr/>
+                    <a:lstStyle/>
+                    <a:p>
+                      <a:r>
+                        <a:rPr sz="950">
+                          <a:solidFill>
+                            <a:srgbClr val="22262B"/>
+                          </a:solidFill>
+                          <a:latin typeface="Calibri"/>
+                        </a:rPr>
+                        <a:t>HAL</a:t>
+                      </a:r>
+                    </a:p>
+                  </a:txBody>
+                  <a:tcPr>
+                    <a:solidFill>
+                      <a:srgbClr val="ECEEF1"/>
+                    </a:solidFill>
+                  </a:tcPr>
+                </a:tc>
+                <a:tc>
+                  <a:txBody>
+                    <a:bodyPr/>
+                    <a:lstStyle/>
+                    <a:p>
+                      <a:r>
+                        <a:rPr sz="950">
+                          <a:solidFill>
+                            <a:srgbClr val="22262B"/>
+                          </a:solidFill>
+                          <a:latin typeface="Calibri"/>
+                        </a:rPr>
+                        <a:t>CVPR'26</a:t>
+                      </a:r>
+                    </a:p>
+                  </a:txBody>
+                  <a:tcPr>
+                    <a:solidFill>
+                      <a:srgbClr val="ECEEF1"/>
+                    </a:solidFill>
+                  </a:tcPr>
+                </a:tc>
+                <a:tc>
+                  <a:txBody>
+                    <a:bodyPr/>
+                    <a:lstStyle/>
+                    <a:p>
+                      <a:r>
+                        <a:rPr sz="950">
+                          <a:solidFill>
+                            <a:srgbClr val="22262B"/>
+                          </a:solidFill>
+                          <a:latin typeface="Calibri"/>
+                        </a:rPr>
+                        <a:t>= ATBA + a VAE regulariser; +2–3 MoF; segmentation-based; skips 50Salads</a:t>
+                      </a:r>
+                    </a:p>
+                  </a:txBody>
+                  <a:tcPr>
+                    <a:solidFill>
+                      <a:srgbClr val="ECEEF1"/>
+                    </a:solidFill>
+                  </a:tcPr>
+                </a:tc>
+                <a:tc>
+                  <a:txBody>
+                    <a:bodyPr/>
+                    <a:lstStyle/>
+                    <a:p>
+                      <a:r>
+                        <a:rPr sz="950">
+                          <a:solidFill>
+                            <a:srgbClr val="22262B"/>
+                          </a:solidFill>
+                          <a:latin typeface="Calibri"/>
+                        </a:rPr>
+                        <a:t>analysed, then DROPPED (no-segmentation)</a:t>
+                      </a:r>
+                    </a:p>
+                  </a:txBody>
+                  <a:tcPr>
+                    <a:solidFill>
+                      <a:srgbClr val="ECEEF1"/>
+                    </a:solidFill>
+                  </a:tcPr>
+                </a:tc>
+              </a:tr>
+              <a:tr h="365760">
+                <a:tc>
+                  <a:txBody>
+                    <a:bodyPr/>
+                    <a:lstStyle/>
+                    <a:p>
+                      <a:r>
+                        <a:rPr sz="950">
+                          <a:solidFill>
+                            <a:srgbClr val="22262B"/>
+                          </a:solidFill>
+                          <a:latin typeface="Calibri"/>
+                        </a:rPr>
+                        <a:t>CVA</a:t>
+                      </a:r>
+                    </a:p>
+                  </a:txBody>
+                  <a:tcPr>
+                    <a:solidFill>
+                      <a:srgbClr val="FFFFFF"/>
+                    </a:solidFill>
+                  </a:tcPr>
+                </a:tc>
+                <a:tc>
+                  <a:txBody>
+                    <a:bodyPr/>
+                    <a:lstStyle/>
+                    <a:p>
+                      <a:r>
+                        <a:rPr sz="950">
+                          <a:solidFill>
+                            <a:srgbClr val="22262B"/>
+                          </a:solidFill>
+                          <a:latin typeface="Calibri"/>
+                        </a:rPr>
+                        <a:t>CVPR'26</a:t>
+                      </a:r>
+                    </a:p>
+                  </a:txBody>
+                  <a:tcPr>
+                    <a:solidFill>
+                      <a:srgbClr val="FFFFFF"/>
+                    </a:solidFill>
+                  </a:tcPr>
+                </a:tc>
+                <a:tc>
+                  <a:txBody>
+                    <a:bodyPr/>
+                    <a:lstStyle/>
+                    <a:p>
+                      <a:r>
+                        <a:rPr sz="950">
+                          <a:solidFill>
+                            <a:srgbClr val="22262B"/>
+                          </a:solidFill>
+                          <a:latin typeface="Calibri"/>
+                        </a:rPr>
+                        <a:t>VLM video-text alignment for grounding; hierarchical encoder + boundary-contrastive loss; SOTA</a:t>
+                      </a:r>
+                    </a:p>
+                  </a:txBody>
+                  <a:tcPr>
+                    <a:solidFill>
+                      <a:srgbClr val="FFFFFF"/>
+                    </a:solidFill>
+                  </a:tcPr>
+                </a:tc>
+                <a:tc>
+                  <a:txBody>
+                    <a:bodyPr/>
+                    <a:lstStyle/>
+                    <a:p>
+                      <a:r>
+                        <a:rPr sz="950">
+                          <a:solidFill>
+                            <a:srgbClr val="22262B"/>
+                          </a:solidFill>
+                          <a:latin typeface="Calibri"/>
+                        </a:rPr>
+                        <a:t>co-intern — the VLM aligner</a:t>
+                      </a:r>
+                    </a:p>
+                  </a:txBody>
+                  <a:tcPr>
+                    <a:solidFill>
+                      <a:srgbClr val="FFFFFF"/>
+                    </a:solidFill>
+                  </a:tcPr>
+                </a:tc>
+              </a:tr>
+              <a:tr h="365760">
+                <a:tc>
+                  <a:txBody>
+                    <a:bodyPr/>
+                    <a:lstStyle/>
+                    <a:p>
+                      <a:r>
+                        <a:rPr sz="950">
+                          <a:solidFill>
+                            <a:srgbClr val="22262B"/>
+                          </a:solidFill>
+                          <a:latin typeface="Calibri"/>
+                        </a:rPr>
+                        <a:t>MASRA</a:t>
+                      </a:r>
+                    </a:p>
+                  </a:txBody>
+                  <a:tcPr>
+                    <a:solidFill>
+                      <a:srgbClr val="ECEEF1"/>
+                    </a:solidFill>
+                  </a:tcPr>
+                </a:tc>
+                <a:tc>
+                  <a:txBody>
+                    <a:bodyPr/>
+                    <a:lstStyle/>
+                    <a:p>
+                      <a:r>
+                        <a:rPr sz="950">
+                          <a:solidFill>
+                            <a:srgbClr val="22262B"/>
+                          </a:solidFill>
+                          <a:latin typeface="Calibri"/>
+                        </a:rPr>
+                        <a:t>2026</a:t>
+                      </a:r>
+                    </a:p>
+                  </a:txBody>
+                  <a:tcPr>
+                    <a:solidFill>
+                      <a:srgbClr val="ECEEF1"/>
+                    </a:solidFill>
+                  </a:tcPr>
+                </a:tc>
+                <a:tc>
+                  <a:txBody>
+                    <a:bodyPr/>
+                    <a:lstStyle/>
+                    <a:p>
+                      <a:r>
+                        <a:rPr sz="950">
+                          <a:solidFill>
+                            <a:srgbClr val="22262B"/>
+                          </a:solidFill>
+                          <a:latin typeface="Calibri"/>
+                        </a:rPr>
+                        <a:t>MLLM-assisted alignment: align a text relation-matrix to the video similarity matrix; MLLM train-only</a:t>
+                      </a:r>
+                    </a:p>
+                  </a:txBody>
+                  <a:tcPr>
+                    <a:solidFill>
+                      <a:srgbClr val="ECEEF1"/>
+                    </a:solidFill>
+                  </a:tcPr>
+                </a:tc>
+                <a:tc>
+                  <a:txBody>
+                    <a:bodyPr/>
+                    <a:lstStyle/>
+                    <a:p>
+                      <a:r>
+                        <a:rPr sz="950">
+                          <a:solidFill>
+                            <a:srgbClr val="22262B"/>
+                          </a:solidFill>
+                          <a:latin typeface="Calibri"/>
+                        </a:rPr>
+                        <a:t>Eliz — the language regulariser</a:t>
+                      </a:r>
+                    </a:p>
+                  </a:txBody>
+                  <a:tcPr>
+                    <a:solidFill>
+                      <a:srgbClr val="ECEEF1"/>
+                    </a:solidFill>
+                  </a:tcPr>
+                </a:tc>
+              </a:tr>
+              <a:tr h="365760">
+                <a:tc>
+                  <a:txBody>
+                    <a:bodyPr/>
+                    <a:lstStyle/>
+                    <a:p>
+                      <a:r>
+                        <a:rPr sz="950">
+                          <a:solidFill>
+                            <a:srgbClr val="22262B"/>
+                          </a:solidFill>
+                          <a:latin typeface="Calibri"/>
+                        </a:rPr>
+                        <a:t>TAN / StepFormer</a:t>
+                      </a:r>
+                    </a:p>
+                  </a:txBody>
+                  <a:tcPr>
+                    <a:solidFill>
+                      <a:srgbClr val="FFFFFF"/>
+                    </a:solidFill>
+                  </a:tcPr>
+                </a:tc>
+                <a:tc>
+                  <a:txBody>
+                    <a:bodyPr/>
+                    <a:lstStyle/>
+                    <a:p>
+                      <a:r>
+                        <a:rPr sz="950">
+                          <a:solidFill>
+                            <a:srgbClr val="22262B"/>
+                          </a:solidFill>
+                          <a:latin typeface="Calibri"/>
+                        </a:rPr>
+                        <a:t>CVPR'22/'23</a:t>
+                      </a:r>
+                    </a:p>
+                  </a:txBody>
+                  <a:tcPr>
+                    <a:solidFill>
+                      <a:srgbClr val="FFFFFF"/>
+                    </a:solidFill>
+                  </a:tcPr>
+                </a:tc>
+                <a:tc>
+                  <a:txBody>
+                    <a:bodyPr/>
+                    <a:lstStyle/>
+                    <a:p>
+                      <a:r>
+                        <a:rPr sz="950">
+                          <a:solidFill>
+                            <a:srgbClr val="22262B"/>
+                          </a:solidFill>
+                          <a:latin typeface="Calibri"/>
+                        </a:rPr>
+                        <a:t>the genuine transcript/sequence→video aligners (weak/self-sup)</a:t>
+                      </a:r>
+                    </a:p>
+                  </a:txBody>
+                  <a:tcPr>
+                    <a:solidFill>
+                      <a:srgbClr val="FFFFFF"/>
+                    </a:solidFill>
+                  </a:tcPr>
+                </a:tc>
+                <a:tc>
+                  <a:txBody>
+                    <a:bodyPr/>
+                    <a:lstStyle/>
+                    <a:p>
+                      <a:r>
+                        <a:rPr sz="950">
+                          <a:solidFill>
+                            <a:srgbClr val="22262B"/>
+                          </a:solidFill>
+                          <a:latin typeface="Calibri"/>
+                        </a:rPr>
+                        <a:t>the alignment mechanism references</a:t>
+                      </a:r>
+                    </a:p>
+                  </a:txBody>
+                  <a:tcPr>
+                    <a:solidFill>
+                      <a:srgbClr val="FFFFFF"/>
+                    </a:solidFill>
+                  </a:tcPr>
+                </a:tc>
+              </a:tr>
+            </a:tbl>
+          </a:graphicData>
+        </a:graphic>
+      </p:graphicFrame>
     </p:spTree>
   </p:cSld>
   <p:clrMapOvr>
@@ -3575,7 +4008,7 @@
                 </a:solidFill>
                 <a:latin typeface="Calibri"/>
               </a:rPr>
-              <a:t>Progress 6 — CVA (CVPR'26), the co-intern's focus</a:t>
+              <a:t>Progress 6 — the two VLM-alignment references</a:t>
             </a:r>
           </a:p>
           <a:p>
@@ -3586,7 +4019,7 @@
                 </a:solidFill>
                 <a:latin typeface="Calibri"/>
               </a:rPr>
-              <a:t>the strongest VLM video-text aligner  ·  adjacent task</a:t>
+              <a:t>CVA = the aligner (co-intern)   ·   MASRA = the language regulariser (Eliz)</a:t>
             </a:r>
           </a:p>
         </p:txBody>
@@ -3668,7 +4101,39 @@
                 </a:solidFill>
                 <a:latin typeface="Calibri"/>
               </a:rPr>
-              <a:t>▸ CVA = Context-aware Video-text Alignment. Task: video temporal grounding (NL query → one time span), fully supervised, SlowFast + CLIP features. SOTA on QVHighlights / Charades-STA / TACoS (+5 R@1).</a:t>
+              <a:t>▸ CVA (CVPR'26) — Context-aware Video-text Alignment.  Task: video temporal grounding (query → span), CLIP+SlowFast, SOTA.  Contribution = the aligner:</a:t>
+            </a:r>
+          </a:p>
+          <a:p>
+            <a:pPr lvl="1">
+              <a:spcAft>
+                <a:spcPts val="600"/>
+              </a:spcAft>
+            </a:pPr>
+            <a:r>
+              <a:rPr sz="1500">
+                <a:solidFill>
+                  <a:srgbClr val="5B6470"/>
+                </a:solidFill>
+                <a:latin typeface="Calibri"/>
+              </a:rPr>
+              <a:t>– CTE hierarchical encoder (windowed self-attn + learnable queries + bidirectional cross-attn)</a:t>
+            </a:r>
+          </a:p>
+          <a:p>
+            <a:pPr lvl="1">
+              <a:spcAft>
+                <a:spcPts val="600"/>
+              </a:spcAft>
+            </a:pPr>
+            <a:r>
+              <a:rPr sz="1500">
+                <a:solidFill>
+                  <a:srgbClr val="5B6470"/>
+                </a:solidFill>
+                <a:latin typeface="Calibri"/>
+              </a:rPr>
+              <a:t>– CBD boundary-contrastive loss + QCD query-aware augmentation.</a:t>
             </a:r>
           </a:p>
           <a:p>
@@ -3684,7 +4149,7 @@
                 </a:solidFill>
                 <a:latin typeface="Calibri"/>
               </a:rPr>
-              <a:t>▸ Different task, but it IS "align through a VLM, done right". Three components:</a:t>
+              <a:t>▸ MASRA (2026) — MLLM-Assisted Semantic-Relational Consistent Alignment.  Same task, CLIP + an MLLM.  Contribution = a training-time language regulariser:</a:t>
             </a:r>
           </a:p>
           <a:p>
@@ -3700,7 +4165,7 @@
                 </a:solidFill>
                 <a:latin typeface="Calibri"/>
               </a:rPr>
-              <a:t>– QCD — query-aware background-mix augmentation (context robustness).</a:t>
+              <a:t>– LRCA — align a text relation-matrix (from MLLM captions) with the video's similarity matrix</a:t>
             </a:r>
           </a:p>
           <a:p>
@@ -3716,7 +4181,7 @@
                 </a:solidFill>
                 <a:latin typeface="Calibri"/>
               </a:rPr>
-              <a:t>– CTE — hierarchical encoder: windowed self-attn + learnable global queries + bidirectional cross-attn.</a:t>
+              <a:t>– ESTA — align pooled temporal context with action/event semantics</a:t>
             </a:r>
           </a:p>
           <a:p>
@@ -3732,7 +4197,7 @@
                 </a:solidFill>
                 <a:latin typeface="Calibri"/>
               </a:rPr>
-              <a:t>– CBD loss — boundary-focused contrastive: boundary-frame reps invariant to context, contrasted vs adjacent + most-similar background.</a:t>
+              <a:t>– MLLM used ONLY at training, discarded at inference  (= DELTA's philosophy).</a:t>
             </a:r>
           </a:p>
           <a:p>
@@ -3748,23 +4213,7 @@
                 </a:solidFill>
                 <a:latin typeface="Calibri"/>
               </a:rPr>
-              <a:t>▸ Not a drop-in baseline (wrong task/supervision) — the methodological reference. CBD and CTE are directly transferable to our aligned pseudo-boundaries.</a:t>
-            </a:r>
-          </a:p>
-          <a:p>
-            <a:pPr>
-              <a:spcAft>
-                <a:spcPts val="600"/>
-              </a:spcAft>
-            </a:pPr>
-            <a:r>
-              <a:rPr sz="1700" b="0">
-                <a:solidFill>
-                  <a:srgbClr val="22262B"/>
-                </a:solidFill>
-                <a:latin typeface="Calibri"/>
-              </a:rPr>
-              <a:t>▸ We'd use InternVideo2 (video-native) as the VLM, not CVA's SlowFast + frame-CLIP.</a:t>
+              <a:t>▸ Both: grounding, supervised, not procedural — we adapt them to transcript-supervised 50Salads.</a:t>
             </a:r>
           </a:p>
         </p:txBody>
@@ -3824,7 +4273,7 @@
                 </a:solidFill>
                 <a:latin typeface="Calibri"/>
               </a:rPr>
-              <a:t>Scoping — two axes, split between us</a:t>
+              <a:t>Scoping — the workstream split</a:t>
             </a:r>
           </a:p>
           <a:p>
@@ -3835,7 +4284,7 @@
                 </a:solidFill>
                 <a:latin typeface="Calibri"/>
               </a:rPr>
-              <a:t>Eliz → HAL   ·   co-intern → CVA</a:t>
+              <a:t>Eliz → MASRA   ·   co-intern → CVA   ·   both VLM</a:t>
             </a:r>
           </a:p>
         </p:txBody>
@@ -3917,23 +4366,17 @@
                 </a:solidFill>
                 <a:latin typeface="Calibri"/>
               </a:rPr>
-              <a:t>▸ Axis 1  —  transcript → dense labels  (our task's TA stage):</a:t>
-            </a:r>
-          </a:p>
-          <a:p>
-            <a:pPr lvl="1">
+              <a:t>▸ Supervisor's direction: the TA must use a VLM; no segmentation-based approach.</a:t>
+            </a:r>
+          </a:p>
+          <a:p>
+            <a:pPr>
               <a:spcAft>
-                <a:spcPts val="600"/>
+                <a:spcPts val="400"/>
               </a:spcAft>
             </a:pPr>
             <a:r>
-              <a:rPr sz="1500">
-                <a:solidFill>
-                  <a:srgbClr val="5B6470"/>
-                </a:solidFill>
-                <a:latin typeface="Calibri"/>
-              </a:rPr>
-              <a:t>– classifier-based alignment:  ATBA (CVPR'24)  →  HAL (CVPR'26)</a:t>
+              <a:t> </a:t>
             </a:r>
           </a:p>
           <a:p>
@@ -3949,23 +4392,23 @@
                 </a:solidFill>
                 <a:latin typeface="Calibri"/>
               </a:rPr>
-              <a:t>▸ Axis 2  —  NL query → span  (adjacent, supervised):</a:t>
-            </a:r>
-          </a:p>
-          <a:p>
-            <a:pPr lvl="1">
+              <a:t>▸ Co-intern → CVA:  build the VLM aligner — CTE encoder + CBD boundary-contrastive loss.</a:t>
+            </a:r>
+          </a:p>
+          <a:p>
+            <a:pPr>
               <a:spcAft>
                 <a:spcPts val="600"/>
               </a:spcAft>
             </a:pPr>
             <a:r>
-              <a:rPr sz="1500">
-                <a:solidFill>
-                  <a:srgbClr val="5B6470"/>
-                </a:solidFill>
-                <a:latin typeface="Calibri"/>
-              </a:rPr>
-              <a:t>– VLM semantic alignment:  CVA (CVPR'26, SOTA)</a:t>
+              <a:rPr sz="1700" b="0">
+                <a:solidFill>
+                  <a:srgbClr val="22262B"/>
+                </a:solidFill>
+                <a:latin typeface="Calibri"/>
+              </a:rPr>
+              <a:t>▸ Eliz → MASRA:  the training-time language regulariser — LRCA / ESTA — that shapes the video↔transcript similarity, then an order-preserving alignment reads Y* off it.</a:t>
             </a:r>
           </a:p>
           <a:p>
@@ -3991,7 +4434,7 @@
                 </a:solidFill>
                 <a:latin typeface="Calibri"/>
               </a:rPr>
-              <a:t>▸ Eliz → HAL:  reproduce, understand, integrate into DELTA's TA, measure the effect on DLTA MoC.</a:t>
+              <a:t>▸ Structurally: CVA produces the alignment; MASRA (like HAL did on the segmentation side) is an auxiliary training signal that improves it — measured on TA metrics, then downstream MoC.</a:t>
             </a:r>
           </a:p>
           <a:p>
@@ -4007,23 +4450,7 @@
                 </a:solidFill>
                 <a:latin typeface="Calibri"/>
               </a:rPr>
-              <a:t>▸ Co-intern → CVA:  the VLM video-text-alignment angle (CBD, CTE, semantic similarity).</a:t>
-            </a:r>
-          </a:p>
-          <a:p>
-            <a:pPr>
-              <a:spcAft>
-                <a:spcPts val="600"/>
-              </a:spcAft>
-            </a:pPr>
-            <a:r>
-              <a:rPr sz="1700" b="0">
-                <a:solidFill>
-                  <a:srgbClr val="22262B"/>
-                </a:solidFill>
-                <a:latin typeface="Calibri"/>
-              </a:rPr>
-              <a:t>▸ Both feed the DELTA VLM-direct method: HAL brings structure/smoothness, CVA brings the VLM alignment.</a:t>
+              <a:t>▸ VLM for both: InternVideo2 (video-native) instead of CVA/MASRA's SlowFast + frame-CLIP.</a:t>
             </a:r>
           </a:p>
         </p:txBody>
@@ -4176,7 +4603,7 @@
                 </a:solidFill>
                 <a:latin typeface="Calibri"/>
               </a:rPr>
-              <a:t>▸ The bottleneck is "alignment through segmentation" — a trained classifier that 50Salads breaks.</a:t>
+              <a:t>▸ "Alignment through segmentation" (ATBA / HAL) is a trained classifier that 50Salads breaks — and the supervisor has ruled it out.</a:t>
             </a:r>
           </a:p>
           <a:p>
@@ -4192,7 +4619,7 @@
                 </a:solidFill>
                 <a:latin typeface="Calibri"/>
               </a:rPr>
-              <a:t>▸ HAL confirms it: the CVPR'26 SOTA is still ATBA-based, +2–3 MoF, never touches 50Salads.</a:t>
+              <a:t>▸ The move: replace the classifier posteriors with a frozen-VLM transcript×frame similarity, then an order-preserving alignment.</a:t>
             </a:r>
           </a:p>
           <a:p>
@@ -4208,7 +4635,7 @@
                 </a:solidFill>
                 <a:latin typeface="Calibri"/>
               </a:rPr>
-              <a:t>▸ DELTA already has optimal-transport alignment (ASOT, --model_type wclot) — the VLM swap is ≈ one line in the cost matrix; everything downstream (CTC, CRF, LTA decoder, eval) is reused.</a:t>
+              <a:t>▸ DELTA already has optimal-transport alignment (ASOT, --model_type wclot) — the VLM swap is ≈ one line in the cost matrix; CTC / CRF / LTA decoder / eval are all reused.</a:t>
             </a:r>
           </a:p>
           <a:p>
@@ -4224,7 +4651,7 @@
                 </a:solidFill>
                 <a:latin typeface="Calibri"/>
               </a:rPr>
-              <a:t>▸ CVA shows VLM video-text alignment + a boundary-contrastive loss is SOTA on the adjacent task.</a:t>
+              <a:t>▸ CVA + MASRA (CVPR'26 / 2026) do VLM video-text alignment for grounding; we adapt them to transcript-supervised dense anticipation — which nobody has done.</a:t>
             </a:r>
           </a:p>
           <a:p>
@@ -4240,7 +4667,7 @@
                 </a:solidFill>
                 <a:latin typeface="Calibri"/>
               </a:rPr>
-              <a:t>▸ Our contribution: bring that into transcript-supervised DLTA, where ATBA/HAL currently win.</a:t>
+              <a:t>▸ HAL analysed and dropped; kept only as a baseline number.</a:t>
             </a:r>
           </a:p>
         </p:txBody>
@@ -4378,9 +4805,9 @@
                 <a:tableStyleId>{5C22544A-7EE6-4342-B048-85BDC9FD1C3A}</a:tableStyleId>
               </a:tblPr>
               <a:tblGrid>
-                <a:gridCol w="2926080"/>
-                <a:gridCol w="4206240"/>
+                <a:gridCol w="2743200"/>
                 <a:gridCol w="3931920"/>
+                <a:gridCol w="4389120"/>
               </a:tblGrid>
               <a:tr h="365760">
                 <a:tc>
@@ -4389,7 +4816,7 @@
                     <a:lstStyle/>
                     <a:p>
                       <a:r>
-                        <a:rPr sz="1200" b="1">
+                        <a:rPr sz="1150" b="1">
                           <a:solidFill>
                             <a:srgbClr val="FFFFFF"/>
                           </a:solidFill>
@@ -4411,7 +4838,7 @@
                     <a:lstStyle/>
                     <a:p>
                       <a:r>
-                        <a:rPr sz="1200" b="1">
+                        <a:rPr sz="1150" b="1">
                           <a:solidFill>
                             <a:srgbClr val="FFFFFF"/>
                           </a:solidFill>
@@ -4433,7 +4860,7 @@
                     <a:lstStyle/>
                     <a:p>
                       <a:r>
-                        <a:rPr sz="1200" b="1">
+                        <a:rPr sz="1150" b="1">
                           <a:solidFill>
                             <a:srgbClr val="FFFFFF"/>
                           </a:solidFill>
@@ -4457,7 +4884,7 @@
                     <a:lstStyle/>
                     <a:p>
                       <a:r>
-                        <a:rPr sz="1100">
+                        <a:rPr sz="1050">
                           <a:solidFill>
                             <a:srgbClr val="22262B"/>
                           </a:solidFill>
@@ -4479,13 +4906,13 @@
                     <a:lstStyle/>
                     <a:p>
                       <a:r>
-                        <a:rPr sz="1100">
-                          <a:solidFill>
-                            <a:srgbClr val="22262B"/>
-                          </a:solidFill>
-                          <a:latin typeface="Calibri"/>
-                        </a:rPr>
-                        <a:t>blocks VLM feature extraction (VLM phases)</a:t>
+                        <a:rPr sz="1050">
+                          <a:solidFill>
+                            <a:srgbClr val="22262B"/>
+                          </a:solidFill>
+                          <a:latin typeface="Calibri"/>
+                        </a:rPr>
+                        <a:t>blocks VLM feature extraction (the core of both tracks)</a:t>
                       </a:r>
                     </a:p>
                   </a:txBody>
@@ -4501,13 +4928,13 @@
                     <a:lstStyle/>
                     <a:p>
                       <a:r>
-                        <a:rPr sz="1100">
-                          <a:solidFill>
-                            <a:srgbClr val="22262B"/>
-                          </a:solidFill>
-                          <a:latin typeface="Calibri"/>
-                        </a:rPr>
-                        <a:t>lab copy; HAL + baselines run now on I3D</a:t>
+                        <a:rPr sz="1050">
+                          <a:solidFill>
+                            <a:srgbClr val="22262B"/>
+                          </a:solidFill>
+                          <a:latin typeface="Calibri"/>
+                        </a:rPr>
+                        <a:t>chase a lab copy; meanwhile reproduce MASRA/CVA on TACoS (cooking VTG benchmark)</a:t>
                       </a:r>
                     </a:p>
                   </a:txBody>
@@ -4525,7 +4952,7 @@
                     <a:lstStyle/>
                     <a:p>
                       <a:r>
-                        <a:rPr sz="1100">
+                        <a:rPr sz="1050">
                           <a:solidFill>
                             <a:srgbClr val="22262B"/>
                           </a:solidFill>
@@ -4547,7 +4974,7 @@
                     <a:lstStyle/>
                     <a:p>
                       <a:r>
-                        <a:rPr sz="1100">
+                        <a:rPr sz="1050">
                           <a:solidFill>
                             <a:srgbClr val="22262B"/>
                           </a:solidFill>
@@ -4569,13 +4996,13 @@
                     <a:lstStyle/>
                     <a:p>
                       <a:r>
-                        <a:rPr sz="1100">
-                          <a:solidFill>
-                            <a:srgbClr val="22262B"/>
-                          </a:solidFill>
-                          <a:latin typeface="Calibri"/>
-                        </a:rPr>
-                        <a:t>cluster; one conda env for ATBA / HAL / WLTA</a:t>
+                        <a:rPr sz="1050">
+                          <a:solidFill>
+                            <a:srgbClr val="22262B"/>
+                          </a:solidFill>
+                          <a:latin typeface="Calibri"/>
+                        </a:rPr>
+                        <a:t>UPC cluster; one conda env</a:t>
                       </a:r>
                     </a:p>
                   </a:txBody>
@@ -4593,7 +5020,7 @@
                     <a:lstStyle/>
                     <a:p>
                       <a:r>
-                        <a:rPr sz="1100">
+                        <a:rPr sz="1050">
                           <a:solidFill>
                             <a:srgbClr val="22262B"/>
                           </a:solidFill>
@@ -4615,13 +5042,13 @@
                     <a:lstStyle/>
                     <a:p>
                       <a:r>
-                        <a:rPr sz="1100">
-                          <a:solidFill>
-                            <a:srgbClr val="22262B"/>
-                          </a:solidFill>
-                          <a:latin typeface="Calibri"/>
-                        </a:rPr>
-                        <a:t>a method can beat ATBA on MoF and not help DELTA's anticipation MoC</a:t>
+                        <a:rPr sz="1050">
+                          <a:solidFill>
+                            <a:srgbClr val="22262B"/>
+                          </a:solidFill>
+                          <a:latin typeface="Calibri"/>
+                        </a:rPr>
+                        <a:t>a method can win on segmentation MoF and not help DELTA's anticipation MoC</a:t>
                       </a:r>
                     </a:p>
                   </a:txBody>
@@ -4637,13 +5064,13 @@
                     <a:lstStyle/>
                     <a:p>
                       <a:r>
-                        <a:rPr sz="1100">
-                          <a:solidFill>
-                            <a:srgbClr val="22262B"/>
-                          </a:solidFill>
-                          <a:latin typeface="Calibri"/>
-                        </a:rPr>
-                        <a:t>always measure pseudo-label MoC + boundary offset, not just MoF</a:t>
+                        <a:rPr sz="1050">
+                          <a:solidFill>
+                            <a:srgbClr val="22262B"/>
+                          </a:solidFill>
+                          <a:latin typeface="Calibri"/>
+                        </a:rPr>
+                        <a:t>always measure pseudo-label MoC + boundary offset, then downstream MoC</a:t>
                       </a:r>
                     </a:p>
                   </a:txBody>
@@ -4661,13 +5088,13 @@
                     <a:lstStyle/>
                     <a:p>
                       <a:r>
-                        <a:rPr sz="1100">
-                          <a:solidFill>
-                            <a:srgbClr val="22262B"/>
-                          </a:solidFill>
-                          <a:latin typeface="Calibri"/>
-                        </a:rPr>
-                        <a:t>DELTA / HAL code is research-grade</a:t>
+                        <a:rPr sz="1050">
+                          <a:solidFill>
+                            <a:srgbClr val="22262B"/>
+                          </a:solidFill>
+                          <a:latin typeface="Calibri"/>
+                        </a:rPr>
+                        <a:t>DELTA code is research-grade</a:t>
                       </a:r>
                     </a:p>
                   </a:txBody>
@@ -4683,7 +5110,7 @@
                     <a:lstStyle/>
                     <a:p>
                       <a:r>
-                        <a:rPr sz="1100">
+                        <a:rPr sz="1050">
                           <a:solidFill>
                             <a:srgbClr val="22262B"/>
                           </a:solidFill>
@@ -4705,7 +5132,7 @@
                     <a:lstStyle/>
                     <a:p>
                       <a:r>
-                        <a:rPr sz="1100">
+                        <a:rPr sz="1050">
                           <a:solidFill>
                             <a:srgbClr val="22262B"/>
                           </a:solidFill>
@@ -4729,13 +5156,13 @@
                     <a:lstStyle/>
                     <a:p>
                       <a:r>
-                        <a:rPr sz="1100">
-                          <a:solidFill>
-                            <a:srgbClr val="22262B"/>
-                          </a:solidFill>
-                          <a:latin typeface="Calibri"/>
-                        </a:rPr>
-                        <a:t>HAL has no 50Salads config</a:t>
+                        <a:rPr sz="1050">
+                          <a:solidFill>
+                            <a:srgbClr val="22262B"/>
+                          </a:solidFill>
+                          <a:latin typeface="Calibri"/>
+                        </a:rPr>
+                        <a:t>MASRA/CVA are grounding + supervised</a:t>
                       </a:r>
                     </a:p>
                   </a:txBody>
@@ -4751,13 +5178,13 @@
                     <a:lstStyle/>
                     <a:p>
                       <a:r>
-                        <a:rPr sz="1100">
-                          <a:solidFill>
-                            <a:srgbClr val="22262B"/>
-                          </a:solidFill>
-                          <a:latin typeface="Calibri"/>
-                        </a:rPr>
-                        <a:t>can't reproduce a reference number there</a:t>
+                        <a:rPr sz="1050">
+                          <a:solidFill>
+                            <a:srgbClr val="22262B"/>
+                          </a:solidFill>
+                          <a:latin typeface="Calibri"/>
+                        </a:rPr>
+                        <a:t>not a drop-in — architecture + losses must be adapted</a:t>
                       </a:r>
                     </a:p>
                   </a:txBody>
@@ -4773,13 +5200,13 @@
                     <a:lstStyle/>
                     <a:p>
                       <a:r>
-                        <a:rPr sz="1100">
-                          <a:solidFill>
-                            <a:srgbClr val="22262B"/>
-                          </a:solidFill>
-                          <a:latin typeface="Calibri"/>
-                        </a:rPr>
-                        <a:t>reproduce on Breakfast; add a 50S config as a task (H4)</a:t>
+                        <a:rPr sz="1050">
+                          <a:solidFill>
+                            <a:srgbClr val="22262B"/>
+                          </a:solidFill>
+                          <a:latin typeface="Calibri"/>
+                        </a:rPr>
+                        <a:t>keep only the transferable pieces (LRCA/ESTA; CTE/CBD); wire into DELTA's ASOT + decoder</a:t>
                       </a:r>
                     </a:p>
                   </a:txBody>
@@ -4920,7 +5347,7 @@
                 </a:solidFill>
                 <a:latin typeface="Calibri"/>
               </a:rPr>
-              <a:t>Scope — 50Salads only, for now</a:t>
+              <a:t>Scope — 50Salads only</a:t>
             </a:r>
           </a:p>
           <a:p>
@@ -4931,7 +5358,7 @@
                 </a:solidFill>
                 <a:latin typeface="Calibri"/>
               </a:rPr>
-              <a:t>one dataset · TA metrics gate the DLTA metrics</a:t>
+              <a:t>VLM-only · TA metrics → DLTA metrics · one dataset</a:t>
             </a:r>
           </a:p>
         </p:txBody>
@@ -5013,7 +5440,23 @@
                 </a:solidFill>
                 <a:latin typeface="Calibri"/>
               </a:rPr>
-              <a:t>▸ No Breakfast. One dataset, evaluated two ways:</a:t>
+              <a:t>▸ No Breakfast, no segmentation-based approach, no HAL workstream (kept as a baseline number).</a:t>
+            </a:r>
+          </a:p>
+          <a:p>
+            <a:pPr>
+              <a:spcAft>
+                <a:spcPts val="600"/>
+              </a:spcAft>
+            </a:pPr>
+            <a:r>
+              <a:rPr sz="1700" b="0">
+                <a:solidFill>
+                  <a:srgbClr val="22262B"/>
+                </a:solidFill>
+                <a:latin typeface="Calibri"/>
+              </a:rPr>
+              <a:t>▸ One dataset, evaluated two ways — TA metrics gate the DLTA metrics:</a:t>
             </a:r>
           </a:p>
           <a:p>
@@ -5029,7 +5472,7 @@
                 </a:solidFill>
                 <a:latin typeface="Calibri"/>
               </a:rPr>
-              <a:t>– TA metrics — is the transcript→frame alignment good?  MoF / MoC / Edit / F1@k / boundary offset on Y* vs GT.</a:t>
+              <a:t>– TA metrics:  MoF / MoC / Edit / F1@{10,25,50} / median per-transition boundary offset — on Y* vs held-out GT.</a:t>
             </a:r>
           </a:p>
           <a:p>
@@ -5045,7 +5488,7 @@
                 </a:solidFill>
                 <a:latin typeface="Calibri"/>
               </a:rPr>
-              <a:t>– DLTA metrics — Obs{20,30}% × Pred{10,20,30,50}% MoC (the DELTA anticipation grid).</a:t>
+              <a:t>– DLTA metrics:  Obs{20,30}% × Pred{10,20,30,50}% MoC — the DELTA anticipation grid.</a:t>
             </a:r>
           </a:p>
           <a:p>
@@ -5061,7 +5504,7 @@
                 </a:solidFill>
                 <a:latin typeface="Calibri"/>
               </a:rPr>
-              <a:t>▸ HAL is tested TA-first (Phase T, a gate); DELTA integration only if it beats ATBA's TA.</a:t>
+              <a:t>▸ Method = frozen VLM (InternVideo2) transcript×frame similarity  →  MASRA-style regularisation (LRCA/ESTA)  →  order-preserving alignment (ASOT, already in DELTA)  →  Y*  →  DELTA decoder.</a:t>
             </a:r>
           </a:p>
           <a:p>
@@ -5077,39 +5520,7 @@
                 </a:solidFill>
                 <a:latin typeface="Calibri"/>
               </a:rPr>
-              <a:t>▸ Codebases: standalone ATBA + HAL repos for Phase T;  DELTA/WLTA (--model_type atba / wclot) for Phase D.</a:t>
-            </a:r>
-          </a:p>
-          <a:p>
-            <a:pPr>
-              <a:spcAft>
-                <a:spcPts val="600"/>
-              </a:spcAft>
-            </a:pPr>
-            <a:r>
-              <a:rPr sz="1700" b="0">
-                <a:solidFill>
-                  <a:srgbClr val="22262B"/>
-                </a:solidFill>
-                <a:latin typeface="Calibri"/>
-              </a:rPr>
-              <a:t>▸ Two tracks: HAL (I3D only, runs now) · VLM / InternVideo2 (needs raw video).</a:t>
-            </a:r>
-          </a:p>
-          <a:p>
-            <a:pPr>
-              <a:spcAft>
-                <a:spcPts val="600"/>
-              </a:spcAft>
-            </a:pPr>
-            <a:r>
-              <a:rPr sz="1700" b="0">
-                <a:solidFill>
-                  <a:srgbClr val="22262B"/>
-                </a:solidFill>
-                <a:latin typeface="Calibri"/>
-              </a:rPr>
-              <a:t>▸ Baselines: naive 0.34 MoC · ATBA · HAL · ATBA-in-DELTA · ASOT-in-DELTA.</a:t>
+              <a:t>▸ Baselines:  naive-uniform 0.34 MoC  ·  ATBA-in-DELTA (--model_type atba)  ·  ASOT-in-DELTA (--model_type wclot)  ·  HAL number (from its paper).</a:t>
             </a:r>
           </a:p>
         </p:txBody>
@@ -5169,7 +5580,7 @@
                 </a:solidFill>
                 <a:latin typeface="Calibri"/>
               </a:rPr>
-              <a:t>My workstream — HAL:  Phase T (gate)  →  Phase D</a:t>
+              <a:t>My workstream — MASRA (M1–M7)</a:t>
             </a:r>
           </a:p>
           <a:p>
@@ -5180,7 +5591,7 @@
                 </a:solidFill>
                 <a:latin typeface="Calibri"/>
               </a:rPr>
-              <a:t>"TA part" = encoder → boundary detector + DP → Y*  (detector+DP identical; only the encoder differs).  I3D features only — no raw video.</a:t>
+              <a:t>frozen VLM similarity + MASRA-style language regularisation → alignment → DELTA.  M1 starts tomorrow.</a:t>
             </a:r>
           </a:p>
         </p:txBody>
@@ -5248,8 +5659,8 @@
               </a:tblPr>
               <a:tblGrid>
                 <a:gridCol w="457200"/>
-                <a:gridCol w="7680960"/>
-                <a:gridCol w="2926080"/>
+                <a:gridCol w="7863840"/>
+                <a:gridCol w="2743200"/>
               </a:tblGrid>
               <a:tr h="365760">
                 <a:tc>
@@ -5332,7 +5743,7 @@
                           </a:solidFill>
                           <a:latin typeface="Calibri"/>
                         </a:rPr>
-                        <a:t>T1</a:t>
+                        <a:t>M1</a:t>
                       </a:r>
                     </a:p>
                   </a:txBody>
@@ -5354,7 +5765,7 @@
                           </a:solidFill>
                           <a:latin typeface="Calibri"/>
                         </a:rPr>
-                        <a:t>Add a 50Salads config to the ATBA repo + the HAL repo (folder structure, transcripts from GT, splits, widen assert)</a:t>
+                        <a:t>Get the MASRA code + a VTG base model; reproduce on TACoS (cooking benchmark — no 50S video needed yet)</a:t>
                       </a:r>
                     </a:p>
                   </a:txBody>
@@ -5376,7 +5787,7 @@
                           </a:solidFill>
                           <a:latin typeface="Calibri"/>
                         </a:rPr>
-                        <a:t>50S runnable in both</a:t>
+                        <a:t>understand LRCA / ESTA / DAI</a:t>
                       </a:r>
                     </a:p>
                   </a:txBody>
@@ -5400,7 +5811,7 @@
                           </a:solidFill>
                           <a:latin typeface="Calibri"/>
                         </a:rPr>
-                        <a:t>T2</a:t>
+                        <a:t>M2</a:t>
                       </a:r>
                     </a:p>
                   </a:txBody>
@@ -5422,7 +5833,7 @@
                           </a:solidFill>
                           <a:latin typeface="Calibri"/>
                         </a:rPr>
-                        <a:t>Train ATBA on 50S (≥3 seeds) → extract Y*_ATBA on the held-out split</a:t>
+                        <a:t>Add an internvideo2 backbone to delta.features.backbones; build s(transcript × frame) for 50S</a:t>
                       </a:r>
                     </a:p>
                   </a:txBody>
@@ -5444,7 +5855,7 @@
                           </a:solidFill>
                           <a:latin typeface="Calibri"/>
                         </a:rPr>
-                        <a:t>TA metrics</a:t>
+                        <a:t>s (N×T)   [needs raw video]</a:t>
                       </a:r>
                     </a:p>
                   </a:txBody>
@@ -5468,7 +5879,7 @@
                           </a:solidFill>
                           <a:latin typeface="Calibri"/>
                         </a:rPr>
-                        <a:t>T3</a:t>
+                        <a:t>M3</a:t>
                       </a:r>
                     </a:p>
                   </a:txBody>
@@ -5490,7 +5901,7 @@
                           </a:solidFill>
                           <a:latin typeface="Calibri"/>
                         </a:rPr>
-                        <a:t>Train HAL on 50S (same seeds) → extract Y*_HAL</a:t>
+                        <a:t>Adapt LRCA — align a transcript relation-matrix (order structure) with the video similarity matrix</a:t>
                       </a:r>
                     </a:p>
                   </a:txBody>
@@ -5512,7 +5923,7 @@
                           </a:solidFill>
                           <a:latin typeface="Calibri"/>
                         </a:rPr>
-                        <a:t>TA metrics</a:t>
+                        <a:t>language regulariser loss</a:t>
                       </a:r>
                     </a:p>
                   </a:txBody>
@@ -5536,7 +5947,7 @@
                           </a:solidFill>
                           <a:latin typeface="Calibri"/>
                         </a:rPr>
-                        <a:t>T4</a:t>
+                        <a:t>M4</a:t>
                       </a:r>
                     </a:p>
                   </a:txBody>
@@ -5558,7 +5969,7 @@
                           </a:solidFill>
                           <a:latin typeface="Calibri"/>
                         </a:rPr>
-                        <a:t>GATE: score Y*_HAL vs Y*_ATBA vs naive floor — MoF, MoC, Edit, F1@{10,25,50}, median boundary offset</a:t>
+                        <a:t>Adapt ESTA — align pooled temporal context with the 17 action-name semantics</a:t>
                       </a:r>
                     </a:p>
                   </a:txBody>
@@ -5580,7 +5991,7 @@
                           </a:solidFill>
                           <a:latin typeface="Calibri"/>
                         </a:rPr>
-                        <a:t>does HAL's TA beat ATBA's TA?</a:t>
+                        <a:t>semantic alignment loss</a:t>
                       </a:r>
                     </a:p>
                   </a:txBody>
@@ -5604,7 +6015,7 @@
                           </a:solidFill>
                           <a:latin typeface="Calibri"/>
                         </a:rPr>
-                        <a:t>—</a:t>
+                        <a:t>M5</a:t>
                       </a:r>
                     </a:p>
                   </a:txBody>
@@ -5626,7 +6037,7 @@
                           </a:solidFill>
                           <a:latin typeface="Calibri"/>
                         </a:rPr>
-                        <a:t>if the gate fails → stop here.  if it passes ↓</a:t>
+                        <a:t>Order-preserving alignment (ASOT / delta.align.ta) reads Y* off the regularised similarity</a:t>
                       </a:r>
                     </a:p>
                   </a:txBody>
@@ -5640,7 +6051,17 @@
                   <a:txBody>
                     <a:bodyPr/>
                     <a:lstStyle/>
-                    <a:p/>
+                    <a:p>
+                      <a:r>
+                        <a:rPr sz="900">
+                          <a:solidFill>
+                            <a:srgbClr val="22262B"/>
+                          </a:solidFill>
+                          <a:latin typeface="Calibri"/>
+                        </a:rPr>
+                        <a:t>Y*</a:t>
+                      </a:r>
+                    </a:p>
                   </a:txBody>
                   <a:tcPr>
                     <a:solidFill>
@@ -5662,7 +6083,7 @@
                           </a:solidFill>
                           <a:latin typeface="Calibri"/>
                         </a:rPr>
-                        <a:t>D1</a:t>
+                        <a:t>M6</a:t>
                       </a:r>
                     </a:p>
                   </a:txBody>
@@ -5684,7 +6105,7 @@
                           </a:solidFill>
                           <a:latin typeface="Calibri"/>
                         </a:rPr>
-                        <a:t>Port HAL's VAE tap + recon/kl/diff losses into DELTA --model_type atba (~70 lines; warm_epc→40)</a:t>
+                        <a:t>Score Y* vs ATBA-in-DELTA / ASOT-in-DELTA / naive floor — TA metrics</a:t>
                       </a:r>
                     </a:p>
                   </a:txBody>
@@ -5706,7 +6127,7 @@
                           </a:solidFill>
                           <a:latin typeface="Calibri"/>
                         </a:rPr>
-                        <a:t>DELTA-atba+HAL</a:t>
+                        <a:t>does VLM+MASRA beat the baselines?</a:t>
                       </a:r>
                     </a:p>
                   </a:txBody>
@@ -5730,7 +6151,7 @@
                           </a:solidFill>
                           <a:latin typeface="Calibri"/>
                         </a:rPr>
-                        <a:t>D2</a:t>
+                        <a:t>M7</a:t>
                       </a:r>
                     </a:p>
                   </a:txBody>
@@ -5752,7 +6173,7 @@
                           </a:solidFill>
                           <a:latin typeface="Calibri"/>
                         </a:rPr>
-                        <a:t>Train DELTA-atba+HAL vs DELTA-atba on 50S → Obs{20,30}% × Pred{10,20,30,50}% MoC; D3 ablate the 3 terms</a:t>
+                        <a:t>Feed best Y* into DELTA's decoder (CTC/CRF/duration unchanged) → Obs%/Pred% MoC</a:t>
                       </a:r>
                     </a:p>
                   </a:txBody>
@@ -5774,7 +6195,7 @@
                           </a:solidFill>
                           <a:latin typeface="Calibri"/>
                         </a:rPr>
-                        <a:t>does the improved TA improve anticipation?</a:t>
+                        <a:t>the downstream result</a:t>
                       </a:r>
                     </a:p>
                   </a:txBody>
@@ -5844,7 +6265,7 @@
                 </a:solidFill>
                 <a:latin typeface="Calibri"/>
               </a:rPr>
-              <a:t>The VLM-direct method — InternVideo2 (V1–V6)</a:t>
+              <a:t>The full method — where CVA + MASRA land</a:t>
             </a:r>
           </a:p>
           <a:p>
@@ -5855,7 +6276,7 @@
                 </a:solidFill>
                 <a:latin typeface="Calibri"/>
               </a:rPr>
-              <a:t>frozen InternVideo2 similarity → alignment → DELTA  ·  + CVA (CBD/CTE) + HAL (smoothness)</a:t>
+              <a:t>InternVideo2 similarity  +  MASRA regulariser (Eliz)  +  CVA aligner (co-intern)  →  DELTA</a:t>
             </a:r>
           </a:p>
         </p:txBody>
@@ -5937,7 +6358,7 @@
                 </a:solidFill>
                 <a:latin typeface="Calibri"/>
               </a:rPr>
-              <a:t>▸ s(n,t) = cos( InternVideo2_text(action_n), InternVideo2_video(clip_t) )  — frozen, video-native (&gt; CVA's SlowFast + frame-CLIP for fine-grained / temporal). No frame classifier.</a:t>
+              <a:t>▸ s(n,t) = cos( InternVideo2_text(action_n), InternVideo2_video(clip_t) )  — frozen, video-native, no classifier.</a:t>
             </a:r>
           </a:p>
           <a:p>
@@ -5953,7 +6374,7 @@
                 </a:solidFill>
                 <a:latin typeface="Calibri"/>
               </a:rPr>
-              <a:t>▸ V1  add an internvideo2 backbone to delta.features.backbones   (~40 lines, can do now)</a:t>
+              <a:t>▸ + MASRA (Eliz):  LRCA / ESTA training-time losses that shape s toward the transcript's semantic-relational structure; MLLM at train only.</a:t>
             </a:r>
           </a:p>
           <a:p>
@@ -5969,7 +6390,7 @@
                 </a:solidFill>
                 <a:latin typeface="Calibri"/>
               </a:rPr>
-              <a:t>▸ V2–V3  extract InternVideo2 video + text features for 50S → build s → diagnostics (zero-shot confusion, boundary peakedness vs I3D's 1.11×)   [needs raw video]</a:t>
+              <a:t>▸ + CVA (co-intern):  CTE-style encoder on the VLM features; CBD boundary-contrastive loss on the aligned boundary frames.</a:t>
             </a:r>
           </a:p>
           <a:p>
@@ -5985,7 +6406,7 @@
                 </a:solidFill>
                 <a:latin typeface="Calibri"/>
               </a:rPr>
-              <a:t>▸ V4  swap s into DELTA's alignment — wclot cost matrix (train.py:548, ~1 line) or atba BoundaryDetector</a:t>
+              <a:t>▸ Order-preserving alignment on s (ASOT — already in DELTA as --model_type wclot, ~1 line to swap the cost matrix)  →  Y*.</a:t>
             </a:r>
           </a:p>
           <a:p>
@@ -6001,7 +6422,7 @@
                 </a:solidFill>
                 <a:latin typeface="Calibri"/>
               </a:rPr>
-              <a:t>▸ V5  + CVA's CBD boundary-contrastive loss on the aligned boundaries; + a CTE-style encoder</a:t>
+              <a:t>▸ Y*  →  DELTA decoder + CRF + duration head (unchanged)  →  Obs%/Pred% MoC on 50Salads.</a:t>
             </a:r>
           </a:p>
           <a:p>
@@ -6017,23 +6438,7 @@
                 </a:solidFill>
                 <a:latin typeface="Calibri"/>
               </a:rPr>
-              <a:t>▸ V6  best Y* → DELTA decoder + CRF + duration head (unchanged) → Obs%/Pred% MoC on 50Salads</a:t>
-            </a:r>
-          </a:p>
-          <a:p>
-            <a:pPr>
-              <a:spcAft>
-                <a:spcPts val="600"/>
-              </a:spcAft>
-            </a:pPr>
-            <a:r>
-              <a:rPr sz="1700" b="0">
-                <a:solidFill>
-                  <a:srgbClr val="22262B"/>
-                </a:solidFill>
-                <a:latin typeface="Calibri"/>
-              </a:rPr>
-              <a:t>▸ + from HAL: the L_s smoothness penalty on the soft assignment (if H7 shows it helps).</a:t>
+              <a:t>▸ Contribution: VLM-direct transcript→frame alignment for weakly-supervised dense anticipation — unaddressed.</a:t>
             </a:r>
           </a:p>
         </p:txBody>
@@ -6093,7 +6498,7 @@
                 </a:solidFill>
                 <a:latin typeface="Calibri"/>
               </a:rPr>
-              <a:t>Sequencing — two tracks, 50Salads only</a:t>
+              <a:t>Sequencing — two VLM tracks, 50Salads</a:t>
             </a:r>
           </a:p>
           <a:p>
@@ -6104,7 +6509,7 @@
                 </a:solidFill>
                 <a:latin typeface="Calibri"/>
               </a:rPr>
-              <a:t>the HAL track has no blocker and starts immediately; Phase T is a gate</a:t>
+              <a:t>both blocked on raw 50Salads video for the 50S runs; TACoS reproduction can start now</a:t>
             </a:r>
           </a:p>
         </p:txBody>
@@ -6171,9 +6576,9 @@
                 <a:tableStyleId>{5C22544A-7EE6-4342-B048-85BDC9FD1C3A}</a:tableStyleId>
               </a:tblPr>
               <a:tblGrid>
-                <a:gridCol w="1005840"/>
-                <a:gridCol w="5120640"/>
-                <a:gridCol w="4937760"/>
+                <a:gridCol w="1097280"/>
+                <a:gridCol w="5212080"/>
+                <a:gridCol w="4754880"/>
               </a:tblGrid>
               <a:tr h="365760">
                 <a:tc>
@@ -6210,7 +6615,7 @@
                           </a:solidFill>
                           <a:latin typeface="Calibri"/>
                         </a:rPr>
-                        <a:t>HAL track — Eliz (no raw video)</a:t>
+                        <a:t>Eliz — MASRA</a:t>
                       </a:r>
                     </a:p>
                   </a:txBody>
@@ -6232,7 +6637,7 @@
                           </a:solidFill>
                           <a:latin typeface="Calibri"/>
                         </a:rPr>
-                        <a:t>VLM track (needs raw video)</a:t>
+                        <a:t>Co-intern — CVA</a:t>
                       </a:r>
                     </a:p>
                   </a:txBody>
@@ -6256,7 +6661,7 @@
                           </a:solidFill>
                           <a:latin typeface="Calibri"/>
                         </a:rPr>
-                        <a:t>Now</a:t>
+                        <a:t>Tomorrow</a:t>
                       </a:r>
                     </a:p>
                   </a:txBody>
@@ -6278,7 +6683,7 @@
                           </a:solidFill>
                           <a:latin typeface="Calibri"/>
                         </a:rPr>
-                        <a:t>T1: 50Salads config for the ATBA + HAL repos; cluster env</a:t>
+                        <a:t>M1: get MASRA code; reproduce on TACoS; read LRCA / ESTA / DAI</a:t>
                       </a:r>
                     </a:p>
                   </a:txBody>
@@ -6300,7 +6705,7 @@
                           </a:solidFill>
                           <a:latin typeface="Calibri"/>
                         </a:rPr>
-                        <a:t>V1: add the internvideo2 backbone</a:t>
+                        <a:t>get CVA code; reproduce on QVHighlights / TACoS</a:t>
                       </a:r>
                     </a:p>
                   </a:txBody>
@@ -6346,7 +6751,7 @@
                           </a:solidFill>
                           <a:latin typeface="Calibri"/>
                         </a:rPr>
-                        <a:t>T2–T3: train ATBA + HAL on 50S (≥3 seeds); extract Y*</a:t>
+                        <a:t>M2: internvideo2 backbone; chase raw 50S video; build s once available</a:t>
                       </a:r>
                     </a:p>
                   </a:txBody>
@@ -6368,7 +6773,7 @@
                           </a:solidFill>
                           <a:latin typeface="Calibri"/>
                         </a:rPr>
-                        <a:t>chase raw 50S video from the lab</a:t>
+                        <a:t>isolate CTE + CBD as reusable modules</a:t>
                       </a:r>
                     </a:p>
                   </a:txBody>
@@ -6392,7 +6797,7 @@
                           </a:solidFill>
                           <a:latin typeface="Calibri"/>
                         </a:rPr>
-                        <a:t>+2 wk</a:t>
+                        <a:t>+2–3 wk</a:t>
                       </a:r>
                     </a:p>
                   </a:txBody>
@@ -6414,7 +6819,7 @@
                           </a:solidFill>
                           <a:latin typeface="Calibri"/>
                         </a:rPr>
-                        <a:t>T4 — GATE: Y*_ATBA vs Y*_HAL vs naive floor</a:t>
+                        <a:t>M3–M4: adapt LRCA / ESTA to the transcript setting</a:t>
                       </a:r>
                     </a:p>
                   </a:txBody>
@@ -6436,7 +6841,7 @@
                           </a:solidFill>
                           <a:latin typeface="Calibri"/>
                         </a:rPr>
-                        <a:t>—</a:t>
+                        <a:t>CTE / CBD on our VLM features (once s exists)</a:t>
                       </a:r>
                     </a:p>
                   </a:txBody>
@@ -6482,7 +6887,7 @@
                           </a:solidFill>
                           <a:latin typeface="Calibri"/>
                         </a:rPr>
-                        <a:t>if gate passes: D1–D2 port HAL into DELTA-atba; Obs%/Pred% MoC</a:t>
+                        <a:t>M5–M6: order-preserving alignment; score Y* (TA metrics) vs baselines</a:t>
                       </a:r>
                     </a:p>
                   </a:txBody>
@@ -6504,7 +6909,7 @@
                           </a:solidFill>
                           <a:latin typeface="Calibri"/>
                         </a:rPr>
-                        <a:t>V2–V3: InternVideo2 extraction; build s; diagnostics</a:t>
+                        <a:t>join: CBD on the aligned boundaries</a:t>
                       </a:r>
                     </a:p>
                   </a:txBody>
@@ -6550,7 +6955,7 @@
                           </a:solidFill>
                           <a:latin typeface="Calibri"/>
                         </a:rPr>
-                        <a:t>D3–D4: ablate; hand diff_loss to the VLM track</a:t>
+                        <a:t>M7: Y* → DELTA decoder → Obs%/Pred% MoC</a:t>
                       </a:r>
                     </a:p>
                   </a:txBody>
@@ -6572,7 +6977,7 @@
                           </a:solidFill>
                           <a:latin typeface="Calibri"/>
                         </a:rPr>
-                        <a:t>V4–V6: swap s into DELTA's alignment; + CVA CBD/CTE; MoC</a:t>
+                        <a:t>ablations; write-up</a:t>
                       </a:r>
                     </a:p>
                   </a:txBody>
@@ -6653,7 +7058,7 @@
                 </a:solidFill>
                 <a:latin typeface="Calibri"/>
               </a:rPr>
-              <a:t>Internship progress review</a:t>
+              <a:t>Internship progress review  ·  pivot: HAL → MASRA (VLM required)</a:t>
             </a:r>
           </a:p>
         </p:txBody>
@@ -6735,7 +7140,7 @@
                 </a:solidFill>
                 <a:latin typeface="Calibri"/>
               </a:rPr>
-              <a:t>▸ Goal: transcript-only Dense Long-Term Action Anticipation (DLTA); focus = the Temporal Alignment (TA) component, first on 50Salads.</a:t>
+              <a:t>▸ Goal: transcript-only Dense Long-Term Action Anticipation (DLTA); focus = the Temporal Alignment (TA) component, on 50Salads.</a:t>
             </a:r>
           </a:p>
           <a:p>
@@ -6751,7 +7156,7 @@
                 </a:solidFill>
                 <a:latin typeface="Calibri"/>
               </a:rPr>
-              <a:t>▸ Direction (per your guidance): a fundamentally different TA — align via a vision-language model, not via segmentation the way ATBA does.</a:t>
+              <a:t>▸ Direction confirmed (your guidance): the TA must use a VLM, NOT segmentation the way ATBA/HAL do.</a:t>
             </a:r>
           </a:p>
           <a:p>
@@ -6767,7 +7172,7 @@
                 </a:solidFill>
                 <a:latin typeface="Calibri"/>
               </a:rPr>
-              <a:t>▸ Done: research repo + infrastructure, 50Salads analysis, a VLM-direct aligner prototype (21 tests); analysed the DELTA code (received) and the two CVPR'26 baselines HAL and CVA.</a:t>
+              <a:t>▸ Done: research repo + infrastructure, 50Salads analysis, a VLM-direct aligner prototype (21 tests); deep-read of the DELTA code (received); analysed the CVPR'25/26 VLM-alignment literature (HAL, CVA, MASRA, TAN, StepFormer, OVTAS, MLLM4WTAL).</a:t>
             </a:r>
           </a:p>
           <a:p>
@@ -6783,7 +7188,23 @@
                 </a:solidFill>
                 <a:latin typeface="Calibri"/>
               </a:rPr>
-              <a:t>▸ Workstream split: Eliz → HAL (integrate + measure on DLTA); co-intern → CVA (the VLM alignment ideas).</a:t>
+              <a:t>▸ Workstream split:  Eliz → MASRA  ·  co-intern → CVA.  Both are VLM video-text alignment.</a:t>
+            </a:r>
+          </a:p>
+          <a:p>
+            <a:pPr lvl="1">
+              <a:spcAft>
+                <a:spcPts val="600"/>
+              </a:spcAft>
+            </a:pPr>
+            <a:r>
+              <a:rPr sz="1500">
+                <a:solidFill>
+                  <a:srgbClr val="5B6470"/>
+                </a:solidFill>
+                <a:latin typeface="Calibri"/>
+              </a:rPr>
+              <a:t>– HAL was analysed then dropped — it is ATBA + a regulariser, still segmentation-based.</a:t>
             </a:r>
           </a:p>
           <a:p>
@@ -6799,7 +7220,7 @@
                 </a:solidFill>
                 <a:latin typeface="Calibri"/>
               </a:rPr>
-              <a:t>▸ Key blocker: raw 50Salads video is unavailable (official host down) — needed for VLM features.</a:t>
+              <a:t>▸ Blocker: raw 50Salads video for VLM feature extraction (official host down).</a:t>
             </a:r>
           </a:p>
           <a:p>
@@ -6815,7 +7236,7 @@
                 </a:solidFill>
                 <a:latin typeface="Calibri"/>
               </a:rPr>
-              <a:t>▸ This deck: what's built, what we learned, the phased TA plan, and questions — for your input.</a:t>
+              <a:t>▸ Next: start building MASRA + its VLM tomorrow.</a:t>
             </a:r>
           </a:p>
         </p:txBody>
@@ -6968,7 +7389,7 @@
                 </a:solidFill>
                 <a:latin typeface="Calibri"/>
               </a:rPr>
-              <a:t>▸ Can the group share raw 50Salads video? (blocks VLM features; official host is down.)</a:t>
+              <a:t>▸ Can the group share raw 50Salads video?  (blocks the VLM feature extraction for both of us.)</a:t>
             </a:r>
           </a:p>
           <a:p>
@@ -6984,7 +7405,7 @@
                 </a:solidFill>
                 <a:latin typeface="Calibri"/>
               </a:rPr>
-              <a:t>▸ HAL workstream: is the goal to integrate it into DELTA (H5–H6), or just a standalone reproduction + comparison? Is a negative result ("doesn't transfer to anticipation") acceptable?</a:t>
+              <a:t>▸ MASRA uses an MLLM at training to generate captions — for us the transcript is already given. Keep the MLLM (to expand labels into descriptions), or drop it and use LRCA/ESTA with the plain labels?</a:t>
             </a:r>
           </a:p>
           <a:p>
@@ -7016,7 +7437,7 @@
                 </a:solidFill>
                 <a:latin typeface="Calibri"/>
               </a:rPr>
-              <a:t>▸ Is establishing a 50Salads transcript-only alignment benchmark (ATBA &amp; HAL skip it) a contribution?</a:t>
+              <a:t>▸ Is establishing a 50Salads transcript-only alignment benchmark a contribution?</a:t>
             </a:r>
           </a:p>
           <a:p>
@@ -7048,7 +7469,7 @@
                 </a:solidFill>
                 <a:latin typeface="Calibri"/>
               </a:rPr>
-              <a:t>▸ Preferred VLM backbone — VideoLLaMA3 vision tower, InternVideo2, CLIP, or something the group uses?</a:t>
+              <a:t>▸ VLM backbone — InternVideo2, or something the group already uses?</a:t>
             </a:r>
           </a:p>
           <a:p>
@@ -7169,7 +7590,7 @@
                 </a:solidFill>
                 <a:latin typeface="Calibri"/>
               </a:rPr>
-              <a:t>Docs: temporal-alignment.md · 50salads-notes.md · delta-code.md · baselines-hal-cva.md · hal-analysis.md · approach.md</a:t>
+              <a:t>Docs: temporal-alignment.md · 50salads-notes.md · delta-code.md · baselines-hal-cva.md · approach.md</a:t>
             </a:r>
           </a:p>
         </p:txBody>
@@ -7473,7 +7894,7 @@
                 </a:solidFill>
                 <a:latin typeface="Calibri"/>
               </a:rPr>
-              <a:t>Two ways to recover temporal structure from a transcript</a:t>
+              <a:t>the TA must use a VLM  ·  CVA + MASRA as the references</a:t>
             </a:r>
           </a:p>
         </p:txBody>
@@ -7555,7 +7976,7 @@
                 </a:solidFill>
                 <a:latin typeface="Calibri"/>
               </a:rPr>
-              <a:t>▸ ATBA / HAL — "alignment THROUGH segmentation":</a:t>
+              <a:t>▸ ATBA / HAL — "alignment THROUGH segmentation"  (ruled out by your no-segmentation guidance):</a:t>
             </a:r>
           </a:p>
           <a:p>
@@ -7571,7 +7992,7 @@
                 </a:solidFill>
                 <a:latin typeface="Calibri"/>
               </a:rPr>
-              <a:t>– frozen I3D  →  trained frame classifier  →  posteriors P  →  boundary + transition scores  →  DP  →  Y*</a:t>
+              <a:t>– frozen I3D  →  trained frame classifier  →  posteriors P  →  boundary/transition scores  →  DP  →  Y*</a:t>
             </a:r>
           </a:p>
           <a:p>
@@ -7587,7 +8008,7 @@
                 </a:solidFill>
                 <a:latin typeface="Calibri"/>
               </a:rPr>
-              <a:t>– the alignment can be no better than that classifier at telling the actions apart.</a:t>
+              <a:t>– the alignment can be no better than that classifier — and on 50Salads (fixed camera, near-duplicate cut_* / add_* actions) it is a near-worst case.</a:t>
             </a:r>
           </a:p>
           <a:p>
@@ -7603,7 +8024,39 @@
                 </a:solidFill>
                 <a:latin typeface="Calibri"/>
               </a:rPr>
-              <a:t>▸ On 50Salads that classifier is a near-worst case: fixed overhead camera, near-duplicate fine-grained actions (cut_tomato / cut_cheese, add_oil / add_vinegar).</a:t>
+              <a:t>▸ Our direction — "alignment THROUGH semantic matching":</a:t>
+            </a:r>
+          </a:p>
+          <a:p>
+            <a:pPr lvl="1">
+              <a:spcAft>
+                <a:spcPts val="600"/>
+              </a:spcAft>
+            </a:pPr>
+            <a:r>
+              <a:rPr sz="1500">
+                <a:solidFill>
+                  <a:srgbClr val="5B6470"/>
+                </a:solidFill>
+                <a:latin typeface="Calibri"/>
+              </a:rPr>
+              <a:t>– frozen VLM:  s(n, t) = sim( text(action_n), video_t )  →  order-preserving alignment  →  Y*</a:t>
+            </a:r>
+          </a:p>
+          <a:p>
+            <a:pPr lvl="1">
+              <a:spcAft>
+                <a:spcPts val="600"/>
+              </a:spcAft>
+            </a:pPr>
+            <a:r>
+              <a:rPr sz="1500">
+                <a:solidFill>
+                  <a:srgbClr val="5B6470"/>
+                </a:solidFill>
+                <a:latin typeface="Calibri"/>
+              </a:rPr>
+              <a:t>– no frame classifier; the fine-grained vocabulary is disambiguated by the noun, from step 0.</a:t>
             </a:r>
           </a:p>
           <a:p>
@@ -7619,7 +8072,7 @@
                 </a:solidFill>
                 <a:latin typeface="Calibri"/>
               </a:rPr>
-              <a:t>▸ Our direction — "alignment THROUGH semantic matching" (and CVA proves it works):</a:t>
+              <a:t>▸ Two CVPR'25/26 papers do exactly this for video temporal grounding, and we adapt them:</a:t>
             </a:r>
           </a:p>
           <a:p>
@@ -7635,7 +8088,7 @@
                 </a:solidFill>
                 <a:latin typeface="Calibri"/>
               </a:rPr>
-              <a:t>– frozen VLM:  s(n, t) = sim( text(action_n), frame_t )  →  monotonic / OT alignment  →  Y*</a:t>
+              <a:t>– CVA (CVPR'26) — the aligner: hierarchical encoder + boundary-contrastive loss.  (co-intern)</a:t>
             </a:r>
           </a:p>
           <a:p>
@@ -7651,23 +8104,7 @@
                 </a:solidFill>
                 <a:latin typeface="Calibri"/>
               </a:rPr>
-              <a:t>– no frame classifier in the alignment path; the fine-grained vocabulary is disambiguated by the noun in the label, from step 0.</a:t>
-            </a:r>
-          </a:p>
-          <a:p>
-            <a:pPr lvl="1">
-              <a:spcAft>
-                <a:spcPts val="600"/>
-              </a:spcAft>
-            </a:pPr>
-            <a:r>
-              <a:rPr sz="1500">
-                <a:solidFill>
-                  <a:srgbClr val="5B6470"/>
-                </a:solidFill>
-                <a:latin typeface="Calibri"/>
-              </a:rPr>
-              <a:t>– CVA (CVPR'26) does exactly this for video temporal grounding and is SOTA (+5 R@1).</a:t>
+              <a:t>– MASRA (2026) — the language regulariser: align a text relation-matrix to the video similarity matrix; MLLM used at training only, discarded at inference.  (Eliz)</a:t>
             </a:r>
           </a:p>
         </p:txBody>

</xml_diff>